<commit_message>
Small update of slides.
</commit_message>
<xml_diff>
--- a/Lab_1_slides_MongoDB Basics.pptx
+++ b/Lab_1_slides_MongoDB Basics.pptx
@@ -5,36 +5,38 @@
     <p:sldMasterId id="2147483648" r:id="rId1"/>
   </p:sldMasterIdLst>
   <p:notesMasterIdLst>
-    <p:notesMasterId r:id="rId29"/>
+    <p:notesMasterId r:id="rId31"/>
   </p:notesMasterIdLst>
   <p:sldIdLst>
-    <p:sldId id="256" r:id="rId2"/>
-    <p:sldId id="257" r:id="rId3"/>
-    <p:sldId id="260" r:id="rId4"/>
-    <p:sldId id="262" r:id="rId5"/>
-    <p:sldId id="263" r:id="rId6"/>
-    <p:sldId id="264" r:id="rId7"/>
-    <p:sldId id="261" r:id="rId8"/>
-    <p:sldId id="265" r:id="rId9"/>
-    <p:sldId id="266" r:id="rId10"/>
-    <p:sldId id="268" r:id="rId11"/>
-    <p:sldId id="273" r:id="rId12"/>
-    <p:sldId id="267" r:id="rId13"/>
-    <p:sldId id="269" r:id="rId14"/>
-    <p:sldId id="271" r:id="rId15"/>
-    <p:sldId id="274" r:id="rId16"/>
-    <p:sldId id="275" r:id="rId17"/>
-    <p:sldId id="276" r:id="rId18"/>
-    <p:sldId id="277" r:id="rId19"/>
-    <p:sldId id="278" r:id="rId20"/>
-    <p:sldId id="279" r:id="rId21"/>
-    <p:sldId id="280" r:id="rId22"/>
-    <p:sldId id="284" r:id="rId23"/>
-    <p:sldId id="282" r:id="rId24"/>
-    <p:sldId id="283" r:id="rId25"/>
-    <p:sldId id="287" r:id="rId26"/>
-    <p:sldId id="285" r:id="rId27"/>
-    <p:sldId id="344" r:id="rId28"/>
+    <p:sldId id="346" r:id="rId2"/>
+    <p:sldId id="256" r:id="rId3"/>
+    <p:sldId id="257" r:id="rId4"/>
+    <p:sldId id="260" r:id="rId5"/>
+    <p:sldId id="262" r:id="rId6"/>
+    <p:sldId id="263" r:id="rId7"/>
+    <p:sldId id="264" r:id="rId8"/>
+    <p:sldId id="261" r:id="rId9"/>
+    <p:sldId id="265" r:id="rId10"/>
+    <p:sldId id="266" r:id="rId11"/>
+    <p:sldId id="268" r:id="rId12"/>
+    <p:sldId id="273" r:id="rId13"/>
+    <p:sldId id="267" r:id="rId14"/>
+    <p:sldId id="269" r:id="rId15"/>
+    <p:sldId id="271" r:id="rId16"/>
+    <p:sldId id="274" r:id="rId17"/>
+    <p:sldId id="275" r:id="rId18"/>
+    <p:sldId id="276" r:id="rId19"/>
+    <p:sldId id="277" r:id="rId20"/>
+    <p:sldId id="278" r:id="rId21"/>
+    <p:sldId id="279" r:id="rId22"/>
+    <p:sldId id="280" r:id="rId23"/>
+    <p:sldId id="284" r:id="rId24"/>
+    <p:sldId id="282" r:id="rId25"/>
+    <p:sldId id="283" r:id="rId26"/>
+    <p:sldId id="287" r:id="rId27"/>
+    <p:sldId id="285" r:id="rId28"/>
+    <p:sldId id="344" r:id="rId29"/>
+    <p:sldId id="348" r:id="rId30"/>
   </p:sldIdLst>
   <p:sldSz cx="12192000" cy="6858000"/>
   <p:notesSz cx="6858000" cy="9144000"/>
@@ -133,6 +135,11 @@
       </a:defRPr>
     </a:lvl9pPr>
   </p:defaultTextStyle>
+  <p:extLst>
+    <p:ext uri="{EFAFB233-063F-42B5-8137-9DF3F51BA10A}">
+      <p15:sldGuideLst xmlns:p15="http://schemas.microsoft.com/office/powerpoint/2012/main"/>
+    </p:ext>
+  </p:extLst>
 </p:presentation>
 </file>
 
@@ -218,7 +225,7 @@
           <a:p>
             <a:fld id="{3DD6F4B9-DE41-4738-8C55-69420E35A0DF}" type="datetimeFigureOut">
               <a:rPr lang="en-GB" smtClean="0"/>
-              <a:t>02/03/2026</a:t>
+              <a:t>06/03/2026</a:t>
             </a:fld>
             <a:endParaRPr lang="en-GB"/>
           </a:p>
@@ -836,7 +843,7 @@
           <a:p>
             <a:fld id="{5CB44E9D-BDE2-4863-859B-83B085A0520B}" type="datetimeFigureOut">
               <a:rPr lang="en-GB" smtClean="0"/>
-              <a:t>01/03/2026</a:t>
+              <a:t>06/03/2026</a:t>
             </a:fld>
             <a:endParaRPr lang="en-GB"/>
           </a:p>
@@ -1036,7 +1043,7 @@
           <a:p>
             <a:fld id="{5CB44E9D-BDE2-4863-859B-83B085A0520B}" type="datetimeFigureOut">
               <a:rPr lang="en-GB" smtClean="0"/>
-              <a:t>01/03/2026</a:t>
+              <a:t>06/03/2026</a:t>
             </a:fld>
             <a:endParaRPr lang="en-GB"/>
           </a:p>
@@ -1246,7 +1253,7 @@
           <a:p>
             <a:fld id="{5CB44E9D-BDE2-4863-859B-83B085A0520B}" type="datetimeFigureOut">
               <a:rPr lang="en-GB" smtClean="0"/>
-              <a:t>01/03/2026</a:t>
+              <a:t>06/03/2026</a:t>
             </a:fld>
             <a:endParaRPr lang="en-GB"/>
           </a:p>
@@ -1737,7 +1744,7 @@
           <a:p>
             <a:fld id="{5CB44E9D-BDE2-4863-859B-83B085A0520B}" type="datetimeFigureOut">
               <a:rPr lang="en-GB" smtClean="0"/>
-              <a:t>01/03/2026</a:t>
+              <a:t>06/03/2026</a:t>
             </a:fld>
             <a:endParaRPr lang="en-GB"/>
           </a:p>
@@ -2013,7 +2020,7 @@
           <a:p>
             <a:fld id="{5CB44E9D-BDE2-4863-859B-83B085A0520B}" type="datetimeFigureOut">
               <a:rPr lang="en-GB" smtClean="0"/>
-              <a:t>01/03/2026</a:t>
+              <a:t>06/03/2026</a:t>
             </a:fld>
             <a:endParaRPr lang="en-GB"/>
           </a:p>
@@ -2281,7 +2288,7 @@
           <a:p>
             <a:fld id="{5CB44E9D-BDE2-4863-859B-83B085A0520B}" type="datetimeFigureOut">
               <a:rPr lang="en-GB" smtClean="0"/>
-              <a:t>01/03/2026</a:t>
+              <a:t>06/03/2026</a:t>
             </a:fld>
             <a:endParaRPr lang="en-GB"/>
           </a:p>
@@ -2696,7 +2703,7 @@
           <a:p>
             <a:fld id="{5CB44E9D-BDE2-4863-859B-83B085A0520B}" type="datetimeFigureOut">
               <a:rPr lang="en-GB" smtClean="0"/>
-              <a:t>01/03/2026</a:t>
+              <a:t>06/03/2026</a:t>
             </a:fld>
             <a:endParaRPr lang="en-GB"/>
           </a:p>
@@ -2838,7 +2845,7 @@
           <a:p>
             <a:fld id="{5CB44E9D-BDE2-4863-859B-83B085A0520B}" type="datetimeFigureOut">
               <a:rPr lang="en-GB" smtClean="0"/>
-              <a:t>01/03/2026</a:t>
+              <a:t>06/03/2026</a:t>
             </a:fld>
             <a:endParaRPr lang="en-GB"/>
           </a:p>
@@ -2951,7 +2958,7 @@
           <a:p>
             <a:fld id="{5CB44E9D-BDE2-4863-859B-83B085A0520B}" type="datetimeFigureOut">
               <a:rPr lang="en-GB" smtClean="0"/>
-              <a:t>01/03/2026</a:t>
+              <a:t>06/03/2026</a:t>
             </a:fld>
             <a:endParaRPr lang="en-GB"/>
           </a:p>
@@ -3264,7 +3271,7 @@
           <a:p>
             <a:fld id="{5CB44E9D-BDE2-4863-859B-83B085A0520B}" type="datetimeFigureOut">
               <a:rPr lang="en-GB" smtClean="0"/>
-              <a:t>01/03/2026</a:t>
+              <a:t>06/03/2026</a:t>
             </a:fld>
             <a:endParaRPr lang="en-GB"/>
           </a:p>
@@ -3553,7 +3560,7 @@
           <a:p>
             <a:fld id="{5CB44E9D-BDE2-4863-859B-83B085A0520B}" type="datetimeFigureOut">
               <a:rPr lang="en-GB" smtClean="0"/>
-              <a:t>01/03/2026</a:t>
+              <a:t>06/03/2026</a:t>
             </a:fld>
             <a:endParaRPr lang="en-GB"/>
           </a:p>
@@ -3796,7 +3803,7 @@
           <a:p>
             <a:fld id="{5CB44E9D-BDE2-4863-859B-83B085A0520B}" type="datetimeFigureOut">
               <a:rPr lang="en-GB" smtClean="0"/>
-              <a:t>01/03/2026</a:t>
+              <a:t>06/03/2026</a:t>
             </a:fld>
             <a:endParaRPr lang="en-GB"/>
           </a:p>
@@ -4219,7 +4226,7 @@
           <p:cNvPr id="2" name="Title 1">
             <a:extLst>
               <a:ext uri="{FF2B5EF4-FFF2-40B4-BE49-F238E27FC236}">
-                <a16:creationId xmlns:a16="http://schemas.microsoft.com/office/drawing/2014/main" id="{3D97D480-80B4-7E59-5874-451606A1E25D}"/>
+                <a16:creationId xmlns:a16="http://schemas.microsoft.com/office/drawing/2014/main" id="{FA1F1186-1018-5159-E775-A7BC24AC5353}"/>
               </a:ext>
             </a:extLst>
           </p:cNvPr>
@@ -4227,7 +4234,7 @@
             <a:spLocks noGrp="1"/>
           </p:cNvSpPr>
           <p:nvPr>
-            <p:ph type="ctrTitle"/>
+            <p:ph type="title"/>
           </p:nvPr>
         </p:nvSpPr>
         <p:spPr/>
@@ -4237,7 +4244,51 @@
           <a:p>
             <a:r>
               <a:rPr lang="en-GB" dirty="0"/>
-              <a:t>MongoDB Basics</a:t>
+              <a:t>Software needed</a:t>
+            </a:r>
+          </a:p>
+        </p:txBody>
+      </p:sp>
+      <p:sp>
+        <p:nvSpPr>
+          <p:cNvPr id="3" name="Content Placeholder 2">
+            <a:extLst>
+              <a:ext uri="{FF2B5EF4-FFF2-40B4-BE49-F238E27FC236}">
+                <a16:creationId xmlns:a16="http://schemas.microsoft.com/office/drawing/2014/main" id="{1FB9BDE9-0947-EAEF-69EF-0C8489837BF9}"/>
+              </a:ext>
+            </a:extLst>
+          </p:cNvPr>
+          <p:cNvSpPr>
+            <a:spLocks noGrp="1"/>
+          </p:cNvSpPr>
+          <p:nvPr>
+            <p:ph idx="1"/>
+          </p:nvPr>
+        </p:nvSpPr>
+        <p:spPr/>
+        <p:txBody>
+          <a:bodyPr/>
+          <a:lstStyle/>
+          <a:p>
+            <a:r>
+              <a:rPr lang="en-GB" dirty="0"/>
+              <a:t>MongoDB Community Server</a:t>
+            </a:r>
+          </a:p>
+          <a:p>
+            <a:r>
+              <a:rPr lang="en-GB" dirty="0" err="1"/>
+              <a:t>mongosh</a:t>
+            </a:r>
+            <a:r>
+              <a:rPr lang="en-GB" dirty="0"/>
+              <a:t> – command line client</a:t>
+            </a:r>
+          </a:p>
+          <a:p>
+            <a:r>
+              <a:rPr lang="en-GB" dirty="0"/>
+              <a:t>Mongo Compass – GUI for database</a:t>
             </a:r>
           </a:p>
         </p:txBody>
@@ -4245,7 +4296,7 @@
     </p:spTree>
     <p:extLst>
       <p:ext uri="{BB962C8B-B14F-4D97-AF65-F5344CB8AC3E}">
-        <p14:creationId xmlns:p14="http://schemas.microsoft.com/office/powerpoint/2010/main" val="1434146520"/>
+        <p14:creationId xmlns:p14="http://schemas.microsoft.com/office/powerpoint/2010/main" val="2099723721"/>
       </p:ext>
     </p:extLst>
   </p:cSld>
@@ -4274,34 +4325,165 @@
       </p:grpSpPr>
       <p:sp>
         <p:nvSpPr>
-          <p:cNvPr id="4" name="Title 1">
-            <a:extLst>
-              <a:ext uri="{FF2B5EF4-FFF2-40B4-BE49-F238E27FC236}">
-                <a16:creationId xmlns:a16="http://schemas.microsoft.com/office/drawing/2014/main" id="{C309BA76-E4FB-050C-659B-DC925767F144}"/>
-              </a:ext>
-            </a:extLst>
-          </p:cNvPr>
-          <p:cNvSpPr>
-            <a:spLocks noGrp="1"/>
+          <p:cNvPr id="14" name="Google Shape;2451;p169">
+            <a:extLst>
+              <a:ext uri="{FF2B5EF4-FFF2-40B4-BE49-F238E27FC236}">
+                <a16:creationId xmlns:a16="http://schemas.microsoft.com/office/drawing/2014/main" id="{058FF298-5B87-3216-F623-6C035C5973C8}"/>
+              </a:ext>
+            </a:extLst>
+          </p:cNvPr>
+          <p:cNvSpPr txBox="1">
+            <a:spLocks/>
           </p:cNvSpPr>
-          <p:nvPr>
-            <p:ph type="title"/>
-          </p:nvPr>
+          <p:nvPr/>
         </p:nvSpPr>
         <p:spPr>
           <a:xfrm>
-            <a:off x="838200" y="2766218"/>
-            <a:ext cx="10515600" cy="1325563"/>
+            <a:off x="830300" y="821000"/>
+            <a:ext cx="9943600" cy="615600"/>
           </a:xfrm>
+          <a:prstGeom prst="rect">
+            <a:avLst/>
+          </a:prstGeom>
         </p:spPr>
         <p:txBody>
-          <a:bodyPr/>
+          <a:bodyPr spcFirstLastPara="1" vert="horz" wrap="square" lIns="0" tIns="0" rIns="0" bIns="0" rtlCol="0" anchor="t" anchorCtr="0">
+            <a:noAutofit/>
+          </a:bodyPr>
+          <a:lstStyle>
+            <a:lvl1pPr algn="l" defTabSz="914400" rtl="0" eaLnBrk="1" latinLnBrk="0" hangingPunct="1">
+              <a:lnSpc>
+                <a:spcPct val="90000"/>
+              </a:lnSpc>
+              <a:spcBef>
+                <a:spcPct val="0"/>
+              </a:spcBef>
+              <a:buNone/>
+              <a:defRPr sz="4400" kern="1200">
+                <a:solidFill>
+                  <a:schemeClr val="tx1"/>
+                </a:solidFill>
+                <a:latin typeface="+mj-lt"/>
+                <a:ea typeface="+mj-ea"/>
+                <a:cs typeface="+mj-cs"/>
+              </a:defRPr>
+            </a:lvl1pPr>
+          </a:lstStyle>
+          <a:p>
+            <a:r>
+              <a:rPr lang="en-GB" sz="4800" dirty="0"/>
+              <a:t>Non-Relational Model: Sharding</a:t>
+            </a:r>
+            <a:endParaRPr lang="en-GB" sz="2000" dirty="0"/>
+          </a:p>
+        </p:txBody>
+      </p:sp>
+      <p:sp>
+        <p:nvSpPr>
+          <p:cNvPr id="15" name="Google Shape;2452;p169">
+            <a:extLst>
+              <a:ext uri="{FF2B5EF4-FFF2-40B4-BE49-F238E27FC236}">
+                <a16:creationId xmlns:a16="http://schemas.microsoft.com/office/drawing/2014/main" id="{87E7EEF5-9F92-CFB7-E820-9408A0587643}"/>
+              </a:ext>
+            </a:extLst>
+          </p:cNvPr>
+          <p:cNvSpPr txBox="1">
+            <a:spLocks/>
+          </p:cNvSpPr>
+          <p:nvPr/>
+        </p:nvSpPr>
+        <p:spPr>
+          <a:xfrm>
+            <a:off x="1132400" y="1956133"/>
+            <a:ext cx="4374800" cy="502000"/>
+          </a:xfrm>
+          <a:prstGeom prst="rect">
+            <a:avLst/>
+          </a:prstGeom>
+        </p:spPr>
+        <p:txBody>
+          <a:bodyPr spcFirstLastPara="1" vert="horz" wrap="square" lIns="0" tIns="0" rIns="0" bIns="0" rtlCol="0" anchor="t" anchorCtr="0">
+            <a:noAutofit/>
+          </a:bodyPr>
+          <a:lstStyle>
+            <a:lvl1pPr algn="l" defTabSz="914400" rtl="0" eaLnBrk="1" latinLnBrk="0" hangingPunct="1">
+              <a:lnSpc>
+                <a:spcPct val="90000"/>
+              </a:lnSpc>
+              <a:spcBef>
+                <a:spcPct val="0"/>
+              </a:spcBef>
+              <a:buNone/>
+              <a:defRPr sz="4400" kern="1200">
+                <a:solidFill>
+                  <a:schemeClr val="tx1"/>
+                </a:solidFill>
+                <a:latin typeface="+mj-lt"/>
+                <a:ea typeface="+mj-ea"/>
+                <a:cs typeface="+mj-cs"/>
+              </a:defRPr>
+            </a:lvl1pPr>
+          </a:lstStyle>
+          <a:p>
+            <a:pPr>
+              <a:lnSpc>
+                <a:spcPct val="100000"/>
+              </a:lnSpc>
+            </a:pPr>
+            <a:endParaRPr lang="en-GB" dirty="0">
+              <a:solidFill>
+                <a:srgbClr val="000000"/>
+              </a:solidFill>
+              <a:latin typeface="+mn-lt"/>
+            </a:endParaRPr>
+          </a:p>
+        </p:txBody>
+      </p:sp>
+      <p:sp>
+        <p:nvSpPr>
+          <p:cNvPr id="22" name="TextBox 21">
+            <a:extLst>
+              <a:ext uri="{FF2B5EF4-FFF2-40B4-BE49-F238E27FC236}">
+                <a16:creationId xmlns:a16="http://schemas.microsoft.com/office/drawing/2014/main" id="{D83D3F4C-B07D-F97C-F3F9-5ED9D17827D1}"/>
+              </a:ext>
+            </a:extLst>
+          </p:cNvPr>
+          <p:cNvSpPr txBox="1"/>
+          <p:nvPr/>
+        </p:nvSpPr>
+        <p:spPr>
+          <a:xfrm>
+            <a:off x="830300" y="1781858"/>
+            <a:ext cx="8370850" cy="954107"/>
+          </a:xfrm>
+          <a:prstGeom prst="rect">
+            <a:avLst/>
+          </a:prstGeom>
+          <a:noFill/>
+        </p:spPr>
+        <p:txBody>
+          <a:bodyPr wrap="square" rtlCol="0">
+            <a:spAutoFit/>
+          </a:bodyPr>
           <a:lstStyle/>
           <a:p>
-            <a:pPr algn="ctr"/>
-            <a:r>
-              <a:rPr lang="en-GB" dirty="0"/>
-              <a:t>MongoDB</a:t>
+            <a:pPr marL="457200" indent="-457200">
+              <a:buFont typeface="Arial" panose="020B0604020202020204" pitchFamily="34" charset="0"/>
+              <a:buChar char="•"/>
+            </a:pPr>
+            <a:r>
+              <a:rPr lang="en-GB" sz="2800" dirty="0"/>
+              <a:t>Concept is the same as in Relational model</a:t>
+            </a:r>
+          </a:p>
+          <a:p>
+            <a:pPr marL="457200" indent="-457200">
+              <a:buFont typeface="Arial" panose="020B0604020202020204" pitchFamily="34" charset="0"/>
+              <a:buChar char="•"/>
+            </a:pPr>
+            <a:r>
+              <a:rPr lang="en-GB" sz="2800" dirty="0"/>
+              <a:t>Sharding is part of the architecture of NoSQL</a:t>
             </a:r>
           </a:p>
         </p:txBody>
@@ -4309,7 +4491,7 @@
     </p:spTree>
     <p:extLst>
       <p:ext uri="{BB962C8B-B14F-4D97-AF65-F5344CB8AC3E}">
-        <p14:creationId xmlns:p14="http://schemas.microsoft.com/office/powerpoint/2010/main" val="3564365239"/>
+        <p14:creationId xmlns:p14="http://schemas.microsoft.com/office/powerpoint/2010/main" val="3116847344"/>
       </p:ext>
     </p:extLst>
   </p:cSld>
@@ -4338,56 +4520,10 @@
       </p:grpSpPr>
       <p:sp>
         <p:nvSpPr>
-          <p:cNvPr id="3" name="Content Placeholder 2">
-            <a:extLst>
-              <a:ext uri="{FF2B5EF4-FFF2-40B4-BE49-F238E27FC236}">
-                <a16:creationId xmlns:a16="http://schemas.microsoft.com/office/drawing/2014/main" id="{3F85D62B-DA6C-CC7E-64D9-9672E6D25EDA}"/>
-              </a:ext>
-            </a:extLst>
-          </p:cNvPr>
-          <p:cNvSpPr>
-            <a:spLocks noGrp="1"/>
-          </p:cNvSpPr>
-          <p:nvPr>
-            <p:ph idx="1"/>
-          </p:nvPr>
-        </p:nvSpPr>
-        <p:spPr/>
-        <p:txBody>
-          <a:bodyPr/>
-          <a:lstStyle/>
-          <a:p>
-            <a:r>
-              <a:rPr lang="en-GB" dirty="0"/>
-              <a:t>Document based</a:t>
-            </a:r>
-          </a:p>
-          <a:p>
-            <a:r>
-              <a:rPr lang="en-GB" dirty="0"/>
-              <a:t>JSON based documents (BSON)</a:t>
-            </a:r>
-          </a:p>
-          <a:p>
-            <a:r>
-              <a:rPr lang="en-GB" dirty="0"/>
-              <a:t>Flexible document structure</a:t>
-            </a:r>
-          </a:p>
-          <a:p>
-            <a:r>
-              <a:rPr lang="en-GB" dirty="0"/>
-              <a:t>Horizontal scaling by design</a:t>
-            </a:r>
-          </a:p>
-        </p:txBody>
-      </p:sp>
-      <p:sp>
-        <p:nvSpPr>
           <p:cNvPr id="4" name="Title 1">
             <a:extLst>
               <a:ext uri="{FF2B5EF4-FFF2-40B4-BE49-F238E27FC236}">
-                <a16:creationId xmlns:a16="http://schemas.microsoft.com/office/drawing/2014/main" id="{715DF565-B6D2-7DA6-1514-A908FB6FB8BA}"/>
+                <a16:creationId xmlns:a16="http://schemas.microsoft.com/office/drawing/2014/main" id="{C309BA76-E4FB-050C-659B-DC925767F144}"/>
               </a:ext>
             </a:extLst>
           </p:cNvPr>
@@ -4400,7 +4536,7 @@
         </p:nvSpPr>
         <p:spPr>
           <a:xfrm>
-            <a:off x="838200" y="365125"/>
+            <a:off x="838200" y="2766218"/>
             <a:ext cx="10515600" cy="1325563"/>
           </a:xfrm>
         </p:spPr>
@@ -4419,7 +4555,7 @@
     </p:spTree>
     <p:extLst>
       <p:ext uri="{BB962C8B-B14F-4D97-AF65-F5344CB8AC3E}">
-        <p14:creationId xmlns:p14="http://schemas.microsoft.com/office/powerpoint/2010/main" val="600932272"/>
+        <p14:creationId xmlns:p14="http://schemas.microsoft.com/office/powerpoint/2010/main" val="3564365239"/>
       </p:ext>
     </p:extLst>
   </p:cSld>
@@ -4448,10 +4584,56 @@
       </p:grpSpPr>
       <p:sp>
         <p:nvSpPr>
-          <p:cNvPr id="2" name="Title 1">
-            <a:extLst>
-              <a:ext uri="{FF2B5EF4-FFF2-40B4-BE49-F238E27FC236}">
-                <a16:creationId xmlns:a16="http://schemas.microsoft.com/office/drawing/2014/main" id="{50EFFFBB-3B18-F8C4-981D-66E1DF2DEA2E}"/>
+          <p:cNvPr id="3" name="Content Placeholder 2">
+            <a:extLst>
+              <a:ext uri="{FF2B5EF4-FFF2-40B4-BE49-F238E27FC236}">
+                <a16:creationId xmlns:a16="http://schemas.microsoft.com/office/drawing/2014/main" id="{3F85D62B-DA6C-CC7E-64D9-9672E6D25EDA}"/>
+              </a:ext>
+            </a:extLst>
+          </p:cNvPr>
+          <p:cNvSpPr>
+            <a:spLocks noGrp="1"/>
+          </p:cNvSpPr>
+          <p:nvPr>
+            <p:ph idx="1"/>
+          </p:nvPr>
+        </p:nvSpPr>
+        <p:spPr/>
+        <p:txBody>
+          <a:bodyPr/>
+          <a:lstStyle/>
+          <a:p>
+            <a:r>
+              <a:rPr lang="en-GB" dirty="0"/>
+              <a:t>Document based</a:t>
+            </a:r>
+          </a:p>
+          <a:p>
+            <a:r>
+              <a:rPr lang="en-GB" dirty="0"/>
+              <a:t>JSON based documents (BSON)</a:t>
+            </a:r>
+          </a:p>
+          <a:p>
+            <a:r>
+              <a:rPr lang="en-GB" dirty="0"/>
+              <a:t>Flexible document structure</a:t>
+            </a:r>
+          </a:p>
+          <a:p>
+            <a:r>
+              <a:rPr lang="en-GB" dirty="0"/>
+              <a:t>Horizontal scaling by design</a:t>
+            </a:r>
+          </a:p>
+        </p:txBody>
+      </p:sp>
+      <p:sp>
+        <p:nvSpPr>
+          <p:cNvPr id="4" name="Title 1">
+            <a:extLst>
+              <a:ext uri="{FF2B5EF4-FFF2-40B4-BE49-F238E27FC236}">
+                <a16:creationId xmlns:a16="http://schemas.microsoft.com/office/drawing/2014/main" id="{715DF565-B6D2-7DA6-1514-A908FB6FB8BA}"/>
               </a:ext>
             </a:extLst>
           </p:cNvPr>
@@ -4462,697 +4644,20 @@
             <p:ph type="title"/>
           </p:nvPr>
         </p:nvSpPr>
-        <p:spPr/>
+        <p:spPr>
+          <a:xfrm>
+            <a:off x="838200" y="365125"/>
+            <a:ext cx="10515600" cy="1325563"/>
+          </a:xfrm>
+        </p:spPr>
         <p:txBody>
           <a:bodyPr/>
           <a:lstStyle/>
           <a:p>
+            <a:pPr algn="ctr"/>
             <a:r>
               <a:rPr lang="en-GB" dirty="0"/>
-              <a:t>Document</a:t>
-            </a:r>
-          </a:p>
-        </p:txBody>
-      </p:sp>
-      <p:sp>
-        <p:nvSpPr>
-          <p:cNvPr id="10" name="TextBox 9">
-            <a:extLst>
-              <a:ext uri="{FF2B5EF4-FFF2-40B4-BE49-F238E27FC236}">
-                <a16:creationId xmlns:a16="http://schemas.microsoft.com/office/drawing/2014/main" id="{9941847D-2D0B-DC28-758C-46E0C2FE5C4C}"/>
-              </a:ext>
-            </a:extLst>
-          </p:cNvPr>
-          <p:cNvSpPr txBox="1"/>
-          <p:nvPr/>
-        </p:nvSpPr>
-        <p:spPr>
-          <a:xfrm>
-            <a:off x="838200" y="2116515"/>
-            <a:ext cx="6096000" cy="3139321"/>
-          </a:xfrm>
-          <a:prstGeom prst="rect">
-            <a:avLst/>
-          </a:prstGeom>
-          <a:noFill/>
-        </p:spPr>
-        <p:txBody>
-          <a:bodyPr wrap="square">
-            <a:spAutoFit/>
-          </a:bodyPr>
-          <a:lstStyle/>
-          <a:p>
-            <a:r>
-              <a:rPr lang="en-GB" b="0" dirty="0">
-                <a:solidFill>
-                  <a:srgbClr val="CCCCCC"/>
-                </a:solidFill>
-                <a:effectLst/>
-                <a:latin typeface="Consolas" panose="020B0609020204030204" pitchFamily="49" charset="0"/>
-              </a:rPr>
-              <a:t>{</a:t>
-            </a:r>
-          </a:p>
-          <a:p>
-            <a:r>
-              <a:rPr lang="en-GB" b="0" dirty="0">
-                <a:solidFill>
-                  <a:srgbClr val="CCCCCC"/>
-                </a:solidFill>
-                <a:effectLst/>
-                <a:latin typeface="Consolas" panose="020B0609020204030204" pitchFamily="49" charset="0"/>
-              </a:rPr>
-              <a:t>  </a:t>
-            </a:r>
-            <a:r>
-              <a:rPr lang="en-GB" b="0" dirty="0">
-                <a:solidFill>
-                  <a:srgbClr val="9CDCFE"/>
-                </a:solidFill>
-                <a:effectLst/>
-                <a:latin typeface="Consolas" panose="020B0609020204030204" pitchFamily="49" charset="0"/>
-              </a:rPr>
-              <a:t>"_id"</a:t>
-            </a:r>
-            <a:r>
-              <a:rPr lang="en-GB" b="0" dirty="0">
-                <a:solidFill>
-                  <a:srgbClr val="CCCCCC"/>
-                </a:solidFill>
-                <a:effectLst/>
-                <a:latin typeface="Consolas" panose="020B0609020204030204" pitchFamily="49" charset="0"/>
-              </a:rPr>
-              <a:t>: </a:t>
-            </a:r>
-            <a:r>
-              <a:rPr lang="en-GB" b="0" dirty="0" err="1">
-                <a:solidFill>
-                  <a:srgbClr val="F44747"/>
-                </a:solidFill>
-                <a:effectLst/>
-                <a:latin typeface="Consolas" panose="020B0609020204030204" pitchFamily="49" charset="0"/>
-              </a:rPr>
-              <a:t>ObjectId</a:t>
-            </a:r>
-            <a:r>
-              <a:rPr lang="en-GB" b="0" dirty="0">
-                <a:solidFill>
-                  <a:srgbClr val="F44747"/>
-                </a:solidFill>
-                <a:effectLst/>
-                <a:latin typeface="Consolas" panose="020B0609020204030204" pitchFamily="49" charset="0"/>
-              </a:rPr>
-              <a:t>(</a:t>
-            </a:r>
-            <a:r>
-              <a:rPr lang="en-GB" b="0" dirty="0">
-                <a:solidFill>
-                  <a:srgbClr val="CE9178"/>
-                </a:solidFill>
-                <a:effectLst/>
-                <a:latin typeface="Consolas" panose="020B0609020204030204" pitchFamily="49" charset="0"/>
-              </a:rPr>
-              <a:t>"607f1f77bcf86cd799439011"</a:t>
-            </a:r>
-            <a:r>
-              <a:rPr lang="en-GB" b="0" dirty="0">
-                <a:solidFill>
-                  <a:srgbClr val="F44747"/>
-                </a:solidFill>
-                <a:effectLst/>
-                <a:latin typeface="Consolas" panose="020B0609020204030204" pitchFamily="49" charset="0"/>
-              </a:rPr>
-              <a:t>)</a:t>
-            </a:r>
-            <a:r>
-              <a:rPr lang="en-GB" b="0" dirty="0">
-                <a:solidFill>
-                  <a:srgbClr val="CCCCCC"/>
-                </a:solidFill>
-                <a:effectLst/>
-                <a:latin typeface="Consolas" panose="020B0609020204030204" pitchFamily="49" charset="0"/>
-              </a:rPr>
-              <a:t>,</a:t>
-            </a:r>
-          </a:p>
-          <a:p>
-            <a:r>
-              <a:rPr lang="en-GB" b="0" dirty="0">
-                <a:solidFill>
-                  <a:srgbClr val="CCCCCC"/>
-                </a:solidFill>
-                <a:effectLst/>
-                <a:latin typeface="Consolas" panose="020B0609020204030204" pitchFamily="49" charset="0"/>
-              </a:rPr>
-              <a:t>  </a:t>
-            </a:r>
-            <a:r>
-              <a:rPr lang="en-GB" b="0" dirty="0">
-                <a:solidFill>
-                  <a:srgbClr val="9CDCFE"/>
-                </a:solidFill>
-                <a:effectLst/>
-                <a:latin typeface="Consolas" panose="020B0609020204030204" pitchFamily="49" charset="0"/>
-              </a:rPr>
-              <a:t>"name"</a:t>
-            </a:r>
-            <a:r>
-              <a:rPr lang="en-GB" b="0" dirty="0">
-                <a:solidFill>
-                  <a:srgbClr val="CCCCCC"/>
-                </a:solidFill>
-                <a:effectLst/>
-                <a:latin typeface="Consolas" panose="020B0609020204030204" pitchFamily="49" charset="0"/>
-              </a:rPr>
-              <a:t>: </a:t>
-            </a:r>
-            <a:r>
-              <a:rPr lang="en-GB" b="0" dirty="0">
-                <a:solidFill>
-                  <a:srgbClr val="CE9178"/>
-                </a:solidFill>
-                <a:effectLst/>
-                <a:latin typeface="Consolas" panose="020B0609020204030204" pitchFamily="49" charset="0"/>
-              </a:rPr>
-              <a:t>"Ivan Petrov"</a:t>
-            </a:r>
-            <a:r>
-              <a:rPr lang="en-GB" b="0" dirty="0">
-                <a:solidFill>
-                  <a:srgbClr val="CCCCCC"/>
-                </a:solidFill>
-                <a:effectLst/>
-                <a:latin typeface="Consolas" panose="020B0609020204030204" pitchFamily="49" charset="0"/>
-              </a:rPr>
-              <a:t>,</a:t>
-            </a:r>
-          </a:p>
-          <a:p>
-            <a:r>
-              <a:rPr lang="en-GB" b="0" dirty="0">
-                <a:solidFill>
-                  <a:srgbClr val="CCCCCC"/>
-                </a:solidFill>
-                <a:effectLst/>
-                <a:latin typeface="Consolas" panose="020B0609020204030204" pitchFamily="49" charset="0"/>
-              </a:rPr>
-              <a:t>  </a:t>
-            </a:r>
-            <a:r>
-              <a:rPr lang="en-GB" b="0" dirty="0">
-                <a:solidFill>
-                  <a:srgbClr val="9CDCFE"/>
-                </a:solidFill>
-                <a:effectLst/>
-                <a:latin typeface="Consolas" panose="020B0609020204030204" pitchFamily="49" charset="0"/>
-              </a:rPr>
-              <a:t>"age"</a:t>
-            </a:r>
-            <a:r>
-              <a:rPr lang="en-GB" b="0" dirty="0">
-                <a:solidFill>
-                  <a:srgbClr val="CCCCCC"/>
-                </a:solidFill>
-                <a:effectLst/>
-                <a:latin typeface="Consolas" panose="020B0609020204030204" pitchFamily="49" charset="0"/>
-              </a:rPr>
-              <a:t>: </a:t>
-            </a:r>
-            <a:r>
-              <a:rPr lang="en-GB" b="0" dirty="0">
-                <a:solidFill>
-                  <a:srgbClr val="B5CEA8"/>
-                </a:solidFill>
-                <a:effectLst/>
-                <a:latin typeface="Consolas" panose="020B0609020204030204" pitchFamily="49" charset="0"/>
-              </a:rPr>
-              <a:t>32</a:t>
-            </a:r>
-            <a:r>
-              <a:rPr lang="en-GB" b="0" dirty="0">
-                <a:solidFill>
-                  <a:srgbClr val="CCCCCC"/>
-                </a:solidFill>
-                <a:effectLst/>
-                <a:latin typeface="Consolas" panose="020B0609020204030204" pitchFamily="49" charset="0"/>
-              </a:rPr>
-              <a:t>,</a:t>
-            </a:r>
-          </a:p>
-          <a:p>
-            <a:r>
-              <a:rPr lang="en-GB" b="0" dirty="0">
-                <a:solidFill>
-                  <a:srgbClr val="CCCCCC"/>
-                </a:solidFill>
-                <a:effectLst/>
-                <a:latin typeface="Consolas" panose="020B0609020204030204" pitchFamily="49" charset="0"/>
-              </a:rPr>
-              <a:t>  </a:t>
-            </a:r>
-            <a:r>
-              <a:rPr lang="en-GB" b="0" dirty="0">
-                <a:solidFill>
-                  <a:srgbClr val="9CDCFE"/>
-                </a:solidFill>
-                <a:effectLst/>
-                <a:latin typeface="Consolas" panose="020B0609020204030204" pitchFamily="49" charset="0"/>
-              </a:rPr>
-              <a:t>"email"</a:t>
-            </a:r>
-            <a:r>
-              <a:rPr lang="en-GB" b="0" dirty="0">
-                <a:solidFill>
-                  <a:srgbClr val="CCCCCC"/>
-                </a:solidFill>
-                <a:effectLst/>
-                <a:latin typeface="Consolas" panose="020B0609020204030204" pitchFamily="49" charset="0"/>
-              </a:rPr>
-              <a:t>: </a:t>
-            </a:r>
-            <a:r>
-              <a:rPr lang="en-GB" b="0" dirty="0">
-                <a:solidFill>
-                  <a:srgbClr val="CE9178"/>
-                </a:solidFill>
-                <a:effectLst/>
-                <a:latin typeface="Consolas" panose="020B0609020204030204" pitchFamily="49" charset="0"/>
-              </a:rPr>
-              <a:t>"ivan.petrov@example.com"</a:t>
-            </a:r>
-            <a:r>
-              <a:rPr lang="en-GB" b="0" dirty="0">
-                <a:solidFill>
-                  <a:srgbClr val="CCCCCC"/>
-                </a:solidFill>
-                <a:effectLst/>
-                <a:latin typeface="Consolas" panose="020B0609020204030204" pitchFamily="49" charset="0"/>
-              </a:rPr>
-              <a:t>,</a:t>
-            </a:r>
-          </a:p>
-          <a:p>
-            <a:r>
-              <a:rPr lang="en-GB" b="0" dirty="0">
-                <a:solidFill>
-                  <a:srgbClr val="CCCCCC"/>
-                </a:solidFill>
-                <a:effectLst/>
-                <a:latin typeface="Consolas" panose="020B0609020204030204" pitchFamily="49" charset="0"/>
-              </a:rPr>
-              <a:t>  </a:t>
-            </a:r>
-            <a:r>
-              <a:rPr lang="en-GB" b="0" dirty="0">
-                <a:solidFill>
-                  <a:srgbClr val="9CDCFE"/>
-                </a:solidFill>
-                <a:effectLst/>
-                <a:latin typeface="Consolas" panose="020B0609020204030204" pitchFamily="49" charset="0"/>
-              </a:rPr>
-              <a:t>"address"</a:t>
-            </a:r>
-            <a:r>
-              <a:rPr lang="en-GB" b="0" dirty="0">
-                <a:solidFill>
-                  <a:srgbClr val="CCCCCC"/>
-                </a:solidFill>
-                <a:effectLst/>
-                <a:latin typeface="Consolas" panose="020B0609020204030204" pitchFamily="49" charset="0"/>
-              </a:rPr>
-              <a:t>: {</a:t>
-            </a:r>
-          </a:p>
-          <a:p>
-            <a:r>
-              <a:rPr lang="en-GB" b="0" dirty="0">
-                <a:solidFill>
-                  <a:srgbClr val="CCCCCC"/>
-                </a:solidFill>
-                <a:effectLst/>
-                <a:latin typeface="Consolas" panose="020B0609020204030204" pitchFamily="49" charset="0"/>
-              </a:rPr>
-              <a:t>    </a:t>
-            </a:r>
-            <a:r>
-              <a:rPr lang="en-GB" b="0" dirty="0">
-                <a:solidFill>
-                  <a:srgbClr val="9CDCFE"/>
-                </a:solidFill>
-                <a:effectLst/>
-                <a:latin typeface="Consolas" panose="020B0609020204030204" pitchFamily="49" charset="0"/>
-              </a:rPr>
-              <a:t>"street"</a:t>
-            </a:r>
-            <a:r>
-              <a:rPr lang="en-GB" b="0" dirty="0">
-                <a:solidFill>
-                  <a:srgbClr val="CCCCCC"/>
-                </a:solidFill>
-                <a:effectLst/>
-                <a:latin typeface="Consolas" panose="020B0609020204030204" pitchFamily="49" charset="0"/>
-              </a:rPr>
-              <a:t>: </a:t>
-            </a:r>
-            <a:r>
-              <a:rPr lang="en-GB" b="0" dirty="0">
-                <a:solidFill>
-                  <a:srgbClr val="CE9178"/>
-                </a:solidFill>
-                <a:effectLst/>
-                <a:latin typeface="Consolas" panose="020B0609020204030204" pitchFamily="49" charset="0"/>
-              </a:rPr>
-              <a:t>"Tsar Boris III N61"</a:t>
-            </a:r>
-            <a:r>
-              <a:rPr lang="en-GB" b="0" dirty="0">
-                <a:solidFill>
-                  <a:srgbClr val="CCCCCC"/>
-                </a:solidFill>
-                <a:effectLst/>
-                <a:latin typeface="Consolas" panose="020B0609020204030204" pitchFamily="49" charset="0"/>
-              </a:rPr>
-              <a:t>,</a:t>
-            </a:r>
-          </a:p>
-          <a:p>
-            <a:r>
-              <a:rPr lang="en-GB" b="0" dirty="0">
-                <a:solidFill>
-                  <a:srgbClr val="CCCCCC"/>
-                </a:solidFill>
-                <a:effectLst/>
-                <a:latin typeface="Consolas" panose="020B0609020204030204" pitchFamily="49" charset="0"/>
-              </a:rPr>
-              <a:t>    </a:t>
-            </a:r>
-            <a:r>
-              <a:rPr lang="en-GB" b="0" dirty="0">
-                <a:solidFill>
-                  <a:srgbClr val="9CDCFE"/>
-                </a:solidFill>
-                <a:effectLst/>
-                <a:latin typeface="Consolas" panose="020B0609020204030204" pitchFamily="49" charset="0"/>
-              </a:rPr>
-              <a:t>"city"</a:t>
-            </a:r>
-            <a:r>
-              <a:rPr lang="en-GB" b="0" dirty="0">
-                <a:solidFill>
-                  <a:srgbClr val="CCCCCC"/>
-                </a:solidFill>
-                <a:effectLst/>
-                <a:latin typeface="Consolas" panose="020B0609020204030204" pitchFamily="49" charset="0"/>
-              </a:rPr>
-              <a:t>: </a:t>
-            </a:r>
-            <a:r>
-              <a:rPr lang="en-GB" b="0" dirty="0">
-                <a:solidFill>
-                  <a:srgbClr val="CE9178"/>
-                </a:solidFill>
-                <a:effectLst/>
-                <a:latin typeface="Consolas" panose="020B0609020204030204" pitchFamily="49" charset="0"/>
-              </a:rPr>
-              <a:t>"Sofia"</a:t>
-            </a:r>
-            <a:endParaRPr lang="en-GB" b="0" dirty="0">
-              <a:solidFill>
-                <a:srgbClr val="CCCCCC"/>
-              </a:solidFill>
-              <a:effectLst/>
-              <a:latin typeface="Consolas" panose="020B0609020204030204" pitchFamily="49" charset="0"/>
-            </a:endParaRPr>
-          </a:p>
-          <a:p>
-            <a:r>
-              <a:rPr lang="en-GB" b="0" dirty="0">
-                <a:solidFill>
-                  <a:srgbClr val="CCCCCC"/>
-                </a:solidFill>
-                <a:effectLst/>
-                <a:latin typeface="Consolas" panose="020B0609020204030204" pitchFamily="49" charset="0"/>
-              </a:rPr>
-              <a:t>  },</a:t>
-            </a:r>
-          </a:p>
-          <a:p>
-            <a:r>
-              <a:rPr lang="en-GB" b="0" dirty="0">
-                <a:solidFill>
-                  <a:srgbClr val="CCCCCC"/>
-                </a:solidFill>
-                <a:effectLst/>
-                <a:latin typeface="Consolas" panose="020B0609020204030204" pitchFamily="49" charset="0"/>
-              </a:rPr>
-              <a:t>  </a:t>
-            </a:r>
-            <a:r>
-              <a:rPr lang="en-GB" b="0" dirty="0">
-                <a:solidFill>
-                  <a:srgbClr val="9CDCFE"/>
-                </a:solidFill>
-                <a:effectLst/>
-                <a:latin typeface="Consolas" panose="020B0609020204030204" pitchFamily="49" charset="0"/>
-              </a:rPr>
-              <a:t>"</a:t>
-            </a:r>
-            <a:r>
-              <a:rPr lang="en-GB" b="0" dirty="0" err="1">
-                <a:solidFill>
-                  <a:srgbClr val="9CDCFE"/>
-                </a:solidFill>
-                <a:effectLst/>
-                <a:latin typeface="Consolas" panose="020B0609020204030204" pitchFamily="49" charset="0"/>
-              </a:rPr>
-              <a:t>favouriteSports</a:t>
-            </a:r>
-            <a:r>
-              <a:rPr lang="en-GB" b="0" dirty="0">
-                <a:solidFill>
-                  <a:srgbClr val="9CDCFE"/>
-                </a:solidFill>
-                <a:effectLst/>
-                <a:latin typeface="Consolas" panose="020B0609020204030204" pitchFamily="49" charset="0"/>
-              </a:rPr>
-              <a:t>"</a:t>
-            </a:r>
-            <a:r>
-              <a:rPr lang="en-GB" b="0" dirty="0">
-                <a:solidFill>
-                  <a:srgbClr val="CCCCCC"/>
-                </a:solidFill>
-                <a:effectLst/>
-                <a:latin typeface="Consolas" panose="020B0609020204030204" pitchFamily="49" charset="0"/>
-              </a:rPr>
-              <a:t> : [</a:t>
-            </a:r>
-            <a:r>
-              <a:rPr lang="en-GB" b="0" dirty="0">
-                <a:solidFill>
-                  <a:srgbClr val="CE9178"/>
-                </a:solidFill>
-                <a:effectLst/>
-                <a:latin typeface="Consolas" panose="020B0609020204030204" pitchFamily="49" charset="0"/>
-              </a:rPr>
-              <a:t>"Cycling"</a:t>
-            </a:r>
-            <a:r>
-              <a:rPr lang="en-GB" b="0" dirty="0">
-                <a:solidFill>
-                  <a:srgbClr val="CCCCCC"/>
-                </a:solidFill>
-                <a:effectLst/>
-                <a:latin typeface="Consolas" panose="020B0609020204030204" pitchFamily="49" charset="0"/>
-              </a:rPr>
-              <a:t>, </a:t>
-            </a:r>
-            <a:r>
-              <a:rPr lang="en-GB" b="0" dirty="0">
-                <a:solidFill>
-                  <a:srgbClr val="CE9178"/>
-                </a:solidFill>
-                <a:effectLst/>
-                <a:latin typeface="Consolas" panose="020B0609020204030204" pitchFamily="49" charset="0"/>
-              </a:rPr>
-              <a:t>"Running"</a:t>
-            </a:r>
-            <a:r>
-              <a:rPr lang="en-GB" b="0" dirty="0">
-                <a:solidFill>
-                  <a:srgbClr val="CCCCCC"/>
-                </a:solidFill>
-                <a:effectLst/>
-                <a:latin typeface="Consolas" panose="020B0609020204030204" pitchFamily="49" charset="0"/>
-              </a:rPr>
-              <a:t>]</a:t>
-            </a:r>
-          </a:p>
-          <a:p>
-            <a:r>
-              <a:rPr lang="en-GB" b="0" dirty="0">
-                <a:solidFill>
-                  <a:srgbClr val="CCCCCC"/>
-                </a:solidFill>
-                <a:effectLst/>
-                <a:latin typeface="Consolas" panose="020B0609020204030204" pitchFamily="49" charset="0"/>
-              </a:rPr>
-              <a:t>}</a:t>
-            </a:r>
-          </a:p>
-        </p:txBody>
-      </p:sp>
-      <p:sp>
-        <p:nvSpPr>
-          <p:cNvPr id="11" name="TextBox 10">
-            <a:extLst>
-              <a:ext uri="{FF2B5EF4-FFF2-40B4-BE49-F238E27FC236}">
-                <a16:creationId xmlns:a16="http://schemas.microsoft.com/office/drawing/2014/main" id="{630C7476-12B0-1EFF-DA4E-E29A8D53D468}"/>
-              </a:ext>
-            </a:extLst>
-          </p:cNvPr>
-          <p:cNvSpPr txBox="1"/>
-          <p:nvPr/>
-        </p:nvSpPr>
-        <p:spPr>
-          <a:xfrm>
-            <a:off x="7620000" y="2116515"/>
-            <a:ext cx="4673074" cy="1733808"/>
-          </a:xfrm>
-          <a:prstGeom prst="rect">
-            <a:avLst/>
-          </a:prstGeom>
-          <a:noFill/>
-        </p:spPr>
-        <p:txBody>
-          <a:bodyPr wrap="none" rtlCol="0">
-            <a:spAutoFit/>
-          </a:bodyPr>
-          <a:lstStyle/>
-          <a:p>
-            <a:pPr rtl="0" fontAlgn="base">
-              <a:spcBef>
-                <a:spcPts val="1000"/>
-              </a:spcBef>
-              <a:spcAft>
-                <a:spcPts val="0"/>
-              </a:spcAft>
-            </a:pPr>
-            <a:r>
-              <a:rPr lang="en-GB" sz="1800" b="0" i="0" u="none" strike="noStrike" dirty="0">
-                <a:solidFill>
-                  <a:srgbClr val="001E2B"/>
-                </a:solidFill>
-                <a:effectLst/>
-                <a:latin typeface="Lexend Deca" panose="020B0604020202020204" charset="0"/>
-              </a:rPr>
-              <a:t>JSON-based; Stored as BSON (binary </a:t>
-            </a:r>
-            <a:r>
-              <a:rPr lang="en-GB" sz="1800" b="0" i="0" u="none" strike="noStrike" dirty="0" err="1">
-                <a:solidFill>
-                  <a:srgbClr val="001E2B"/>
-                </a:solidFill>
-                <a:effectLst/>
-                <a:latin typeface="Lexend Deca" panose="020B0604020202020204" charset="0"/>
-              </a:rPr>
-              <a:t>json</a:t>
-            </a:r>
-            <a:r>
-              <a:rPr lang="en-GB" sz="1800" b="0" i="0" u="none" strike="noStrike" dirty="0">
-                <a:solidFill>
-                  <a:srgbClr val="001E2B"/>
-                </a:solidFill>
-                <a:effectLst/>
-                <a:latin typeface="Lexend Deca" panose="020B0604020202020204" charset="0"/>
-              </a:rPr>
-              <a:t>)</a:t>
-            </a:r>
-          </a:p>
-          <a:p>
-            <a:pPr rtl="0" fontAlgn="base">
-              <a:spcBef>
-                <a:spcPts val="1000"/>
-              </a:spcBef>
-              <a:spcAft>
-                <a:spcPts val="0"/>
-              </a:spcAft>
-            </a:pPr>
-            <a:r>
-              <a:rPr lang="en-GB" sz="1800" b="0" i="0" u="none" strike="noStrike" dirty="0">
-                <a:solidFill>
-                  <a:srgbClr val="001E2B"/>
-                </a:solidFill>
-                <a:effectLst/>
-                <a:latin typeface="Lexend Deca" panose="020B0604020202020204" charset="0"/>
-              </a:rPr>
-              <a:t>Consists of:</a:t>
-            </a:r>
-          </a:p>
-          <a:p>
-            <a:pPr marL="285750" indent="-285750" rtl="0" fontAlgn="base">
-              <a:spcBef>
-                <a:spcPts val="1000"/>
-              </a:spcBef>
-              <a:spcAft>
-                <a:spcPts val="0"/>
-              </a:spcAft>
-              <a:buFont typeface="Arial" panose="020B0604020202020204" pitchFamily="34" charset="0"/>
-              <a:buChar char="•"/>
-            </a:pPr>
-            <a:r>
-              <a:rPr lang="en-GB" sz="1800" b="0" i="0" u="none" strike="noStrike" dirty="0">
-                <a:solidFill>
-                  <a:srgbClr val="001E2B"/>
-                </a:solidFill>
-                <a:effectLst/>
-                <a:latin typeface="Lexend Deca" panose="020B0604020202020204" charset="0"/>
-              </a:rPr>
-              <a:t>Fields (Attributes)</a:t>
-            </a:r>
-          </a:p>
-          <a:p>
-            <a:pPr marL="285750" indent="-285750" rtl="0" fontAlgn="base">
-              <a:spcBef>
-                <a:spcPts val="0"/>
-              </a:spcBef>
-              <a:spcAft>
-                <a:spcPts val="0"/>
-              </a:spcAft>
-              <a:buFont typeface="Arial" panose="020B0604020202020204" pitchFamily="34" charset="0"/>
-              <a:buChar char="•"/>
-            </a:pPr>
-            <a:r>
-              <a:rPr lang="en-GB" sz="1800" b="0" i="0" u="none" strike="noStrike" dirty="0">
-                <a:solidFill>
-                  <a:srgbClr val="001E2B"/>
-                </a:solidFill>
-                <a:effectLst/>
-                <a:latin typeface="Lexend Deca" panose="020B0604020202020204" charset="0"/>
-              </a:rPr>
-              <a:t>Sub-documents (Objects)</a:t>
-            </a:r>
-          </a:p>
-          <a:p>
-            <a:pPr marL="285750" indent="-285750" rtl="0" fontAlgn="base">
-              <a:spcBef>
-                <a:spcPts val="0"/>
-              </a:spcBef>
-              <a:spcAft>
-                <a:spcPts val="1000"/>
-              </a:spcAft>
-              <a:buFont typeface="Arial" panose="020B0604020202020204" pitchFamily="34" charset="0"/>
-              <a:buChar char="•"/>
-            </a:pPr>
-            <a:r>
-              <a:rPr lang="en-GB" sz="1800" b="0" i="0" u="none" strike="noStrike" dirty="0">
-                <a:solidFill>
-                  <a:srgbClr val="001E2B"/>
-                </a:solidFill>
-                <a:effectLst/>
-                <a:latin typeface="Lexend Deca" panose="020B0604020202020204" charset="0"/>
-              </a:rPr>
-              <a:t>Arrays</a:t>
+              <a:t>MongoDB</a:t>
             </a:r>
           </a:p>
         </p:txBody>
@@ -5160,7 +4665,7 @@
     </p:spTree>
     <p:extLst>
       <p:ext uri="{BB962C8B-B14F-4D97-AF65-F5344CB8AC3E}">
-        <p14:creationId xmlns:p14="http://schemas.microsoft.com/office/powerpoint/2010/main" val="1663318664"/>
+        <p14:creationId xmlns:p14="http://schemas.microsoft.com/office/powerpoint/2010/main" val="600932272"/>
       </p:ext>
     </p:extLst>
   </p:cSld>
@@ -5192,6 +4697,767 @@
           <p:cNvPr id="2" name="Title 1">
             <a:extLst>
               <a:ext uri="{FF2B5EF4-FFF2-40B4-BE49-F238E27FC236}">
+                <a16:creationId xmlns:a16="http://schemas.microsoft.com/office/drawing/2014/main" id="{50EFFFBB-3B18-F8C4-981D-66E1DF2DEA2E}"/>
+              </a:ext>
+            </a:extLst>
+          </p:cNvPr>
+          <p:cNvSpPr>
+            <a:spLocks noGrp="1"/>
+          </p:cNvSpPr>
+          <p:nvPr>
+            <p:ph type="title"/>
+          </p:nvPr>
+        </p:nvSpPr>
+        <p:spPr/>
+        <p:txBody>
+          <a:bodyPr/>
+          <a:lstStyle/>
+          <a:p>
+            <a:r>
+              <a:rPr lang="en-GB" dirty="0"/>
+              <a:t>Document</a:t>
+            </a:r>
+          </a:p>
+        </p:txBody>
+      </p:sp>
+      <p:sp>
+        <p:nvSpPr>
+          <p:cNvPr id="10" name="TextBox 9">
+            <a:extLst>
+              <a:ext uri="{FF2B5EF4-FFF2-40B4-BE49-F238E27FC236}">
+                <a16:creationId xmlns:a16="http://schemas.microsoft.com/office/drawing/2014/main" id="{9941847D-2D0B-DC28-758C-46E0C2FE5C4C}"/>
+              </a:ext>
+            </a:extLst>
+          </p:cNvPr>
+          <p:cNvSpPr txBox="1"/>
+          <p:nvPr/>
+        </p:nvSpPr>
+        <p:spPr>
+          <a:xfrm>
+            <a:off x="838200" y="2116515"/>
+            <a:ext cx="6096000" cy="3139321"/>
+          </a:xfrm>
+          <a:prstGeom prst="rect">
+            <a:avLst/>
+          </a:prstGeom>
+          <a:noFill/>
+        </p:spPr>
+        <p:txBody>
+          <a:bodyPr wrap="square">
+            <a:spAutoFit/>
+          </a:bodyPr>
+          <a:lstStyle/>
+          <a:p>
+            <a:r>
+              <a:rPr lang="en-GB" b="0" dirty="0">
+                <a:solidFill>
+                  <a:srgbClr val="CCCCCC"/>
+                </a:solidFill>
+                <a:effectLst/>
+                <a:latin typeface="Consolas" panose="020B0609020204030204" pitchFamily="49" charset="0"/>
+              </a:rPr>
+              <a:t>{</a:t>
+            </a:r>
+          </a:p>
+          <a:p>
+            <a:r>
+              <a:rPr lang="en-GB" b="0" dirty="0">
+                <a:solidFill>
+                  <a:srgbClr val="CCCCCC"/>
+                </a:solidFill>
+                <a:effectLst/>
+                <a:latin typeface="Consolas" panose="020B0609020204030204" pitchFamily="49" charset="0"/>
+              </a:rPr>
+              <a:t>  </a:t>
+            </a:r>
+            <a:r>
+              <a:rPr lang="en-GB" b="0" dirty="0">
+                <a:solidFill>
+                  <a:srgbClr val="9CDCFE"/>
+                </a:solidFill>
+                <a:effectLst/>
+                <a:latin typeface="Consolas" panose="020B0609020204030204" pitchFamily="49" charset="0"/>
+              </a:rPr>
+              <a:t>"_id"</a:t>
+            </a:r>
+            <a:r>
+              <a:rPr lang="en-GB" b="0" dirty="0">
+                <a:solidFill>
+                  <a:srgbClr val="CCCCCC"/>
+                </a:solidFill>
+                <a:effectLst/>
+                <a:latin typeface="Consolas" panose="020B0609020204030204" pitchFamily="49" charset="0"/>
+              </a:rPr>
+              <a:t>: </a:t>
+            </a:r>
+            <a:r>
+              <a:rPr lang="en-GB" b="0" dirty="0" err="1">
+                <a:solidFill>
+                  <a:srgbClr val="F44747"/>
+                </a:solidFill>
+                <a:effectLst/>
+                <a:latin typeface="Consolas" panose="020B0609020204030204" pitchFamily="49" charset="0"/>
+              </a:rPr>
+              <a:t>ObjectId</a:t>
+            </a:r>
+            <a:r>
+              <a:rPr lang="en-GB" b="0" dirty="0">
+                <a:solidFill>
+                  <a:srgbClr val="F44747"/>
+                </a:solidFill>
+                <a:effectLst/>
+                <a:latin typeface="Consolas" panose="020B0609020204030204" pitchFamily="49" charset="0"/>
+              </a:rPr>
+              <a:t>(</a:t>
+            </a:r>
+            <a:r>
+              <a:rPr lang="en-GB" b="0" dirty="0">
+                <a:solidFill>
+                  <a:srgbClr val="CE9178"/>
+                </a:solidFill>
+                <a:effectLst/>
+                <a:latin typeface="Consolas" panose="020B0609020204030204" pitchFamily="49" charset="0"/>
+              </a:rPr>
+              <a:t>"607f1f77bcf86cd799439011"</a:t>
+            </a:r>
+            <a:r>
+              <a:rPr lang="en-GB" b="0" dirty="0">
+                <a:solidFill>
+                  <a:srgbClr val="F44747"/>
+                </a:solidFill>
+                <a:effectLst/>
+                <a:latin typeface="Consolas" panose="020B0609020204030204" pitchFamily="49" charset="0"/>
+              </a:rPr>
+              <a:t>)</a:t>
+            </a:r>
+            <a:r>
+              <a:rPr lang="en-GB" b="0" dirty="0">
+                <a:solidFill>
+                  <a:srgbClr val="CCCCCC"/>
+                </a:solidFill>
+                <a:effectLst/>
+                <a:latin typeface="Consolas" panose="020B0609020204030204" pitchFamily="49" charset="0"/>
+              </a:rPr>
+              <a:t>,</a:t>
+            </a:r>
+          </a:p>
+          <a:p>
+            <a:r>
+              <a:rPr lang="en-GB" b="0" dirty="0">
+                <a:solidFill>
+                  <a:srgbClr val="CCCCCC"/>
+                </a:solidFill>
+                <a:effectLst/>
+                <a:latin typeface="Consolas" panose="020B0609020204030204" pitchFamily="49" charset="0"/>
+              </a:rPr>
+              <a:t>  </a:t>
+            </a:r>
+            <a:r>
+              <a:rPr lang="en-GB" b="0" dirty="0">
+                <a:solidFill>
+                  <a:srgbClr val="9CDCFE"/>
+                </a:solidFill>
+                <a:effectLst/>
+                <a:latin typeface="Consolas" panose="020B0609020204030204" pitchFamily="49" charset="0"/>
+              </a:rPr>
+              <a:t>"name"</a:t>
+            </a:r>
+            <a:r>
+              <a:rPr lang="en-GB" b="0" dirty="0">
+                <a:solidFill>
+                  <a:srgbClr val="CCCCCC"/>
+                </a:solidFill>
+                <a:effectLst/>
+                <a:latin typeface="Consolas" panose="020B0609020204030204" pitchFamily="49" charset="0"/>
+              </a:rPr>
+              <a:t>: </a:t>
+            </a:r>
+            <a:r>
+              <a:rPr lang="en-GB" b="0" dirty="0">
+                <a:solidFill>
+                  <a:srgbClr val="CE9178"/>
+                </a:solidFill>
+                <a:effectLst/>
+                <a:latin typeface="Consolas" panose="020B0609020204030204" pitchFamily="49" charset="0"/>
+              </a:rPr>
+              <a:t>"Ivan Petrov"</a:t>
+            </a:r>
+            <a:r>
+              <a:rPr lang="en-GB" b="0" dirty="0">
+                <a:solidFill>
+                  <a:srgbClr val="CCCCCC"/>
+                </a:solidFill>
+                <a:effectLst/>
+                <a:latin typeface="Consolas" panose="020B0609020204030204" pitchFamily="49" charset="0"/>
+              </a:rPr>
+              <a:t>,</a:t>
+            </a:r>
+          </a:p>
+          <a:p>
+            <a:r>
+              <a:rPr lang="en-GB" b="0" dirty="0">
+                <a:solidFill>
+                  <a:srgbClr val="CCCCCC"/>
+                </a:solidFill>
+                <a:effectLst/>
+                <a:latin typeface="Consolas" panose="020B0609020204030204" pitchFamily="49" charset="0"/>
+              </a:rPr>
+              <a:t>  </a:t>
+            </a:r>
+            <a:r>
+              <a:rPr lang="en-GB" b="0" dirty="0">
+                <a:solidFill>
+                  <a:srgbClr val="9CDCFE"/>
+                </a:solidFill>
+                <a:effectLst/>
+                <a:latin typeface="Consolas" panose="020B0609020204030204" pitchFamily="49" charset="0"/>
+              </a:rPr>
+              <a:t>"age"</a:t>
+            </a:r>
+            <a:r>
+              <a:rPr lang="en-GB" b="0" dirty="0">
+                <a:solidFill>
+                  <a:srgbClr val="CCCCCC"/>
+                </a:solidFill>
+                <a:effectLst/>
+                <a:latin typeface="Consolas" panose="020B0609020204030204" pitchFamily="49" charset="0"/>
+              </a:rPr>
+              <a:t>: </a:t>
+            </a:r>
+            <a:r>
+              <a:rPr lang="en-GB" b="0" dirty="0">
+                <a:solidFill>
+                  <a:srgbClr val="B5CEA8"/>
+                </a:solidFill>
+                <a:effectLst/>
+                <a:latin typeface="Consolas" panose="020B0609020204030204" pitchFamily="49" charset="0"/>
+              </a:rPr>
+              <a:t>32</a:t>
+            </a:r>
+            <a:r>
+              <a:rPr lang="en-GB" b="0" dirty="0">
+                <a:solidFill>
+                  <a:srgbClr val="CCCCCC"/>
+                </a:solidFill>
+                <a:effectLst/>
+                <a:latin typeface="Consolas" panose="020B0609020204030204" pitchFamily="49" charset="0"/>
+              </a:rPr>
+              <a:t>,</a:t>
+            </a:r>
+          </a:p>
+          <a:p>
+            <a:r>
+              <a:rPr lang="en-GB" b="0" dirty="0">
+                <a:solidFill>
+                  <a:srgbClr val="CCCCCC"/>
+                </a:solidFill>
+                <a:effectLst/>
+                <a:latin typeface="Consolas" panose="020B0609020204030204" pitchFamily="49" charset="0"/>
+              </a:rPr>
+              <a:t>  </a:t>
+            </a:r>
+            <a:r>
+              <a:rPr lang="en-GB" b="0" dirty="0">
+                <a:solidFill>
+                  <a:srgbClr val="9CDCFE"/>
+                </a:solidFill>
+                <a:effectLst/>
+                <a:latin typeface="Consolas" panose="020B0609020204030204" pitchFamily="49" charset="0"/>
+              </a:rPr>
+              <a:t>"email"</a:t>
+            </a:r>
+            <a:r>
+              <a:rPr lang="en-GB" b="0" dirty="0">
+                <a:solidFill>
+                  <a:srgbClr val="CCCCCC"/>
+                </a:solidFill>
+                <a:effectLst/>
+                <a:latin typeface="Consolas" panose="020B0609020204030204" pitchFamily="49" charset="0"/>
+              </a:rPr>
+              <a:t>: </a:t>
+            </a:r>
+            <a:r>
+              <a:rPr lang="en-GB" b="0" dirty="0">
+                <a:solidFill>
+                  <a:srgbClr val="CE9178"/>
+                </a:solidFill>
+                <a:effectLst/>
+                <a:latin typeface="Consolas" panose="020B0609020204030204" pitchFamily="49" charset="0"/>
+              </a:rPr>
+              <a:t>"ivan.petrov@example.com"</a:t>
+            </a:r>
+            <a:r>
+              <a:rPr lang="en-GB" b="0" dirty="0">
+                <a:solidFill>
+                  <a:srgbClr val="CCCCCC"/>
+                </a:solidFill>
+                <a:effectLst/>
+                <a:latin typeface="Consolas" panose="020B0609020204030204" pitchFamily="49" charset="0"/>
+              </a:rPr>
+              <a:t>,</a:t>
+            </a:r>
+          </a:p>
+          <a:p>
+            <a:r>
+              <a:rPr lang="en-GB" b="0" dirty="0">
+                <a:solidFill>
+                  <a:srgbClr val="CCCCCC"/>
+                </a:solidFill>
+                <a:effectLst/>
+                <a:latin typeface="Consolas" panose="020B0609020204030204" pitchFamily="49" charset="0"/>
+              </a:rPr>
+              <a:t>  </a:t>
+            </a:r>
+            <a:r>
+              <a:rPr lang="en-GB" b="0" dirty="0">
+                <a:solidFill>
+                  <a:srgbClr val="9CDCFE"/>
+                </a:solidFill>
+                <a:effectLst/>
+                <a:latin typeface="Consolas" panose="020B0609020204030204" pitchFamily="49" charset="0"/>
+              </a:rPr>
+              <a:t>"address"</a:t>
+            </a:r>
+            <a:r>
+              <a:rPr lang="en-GB" b="0" dirty="0">
+                <a:solidFill>
+                  <a:srgbClr val="CCCCCC"/>
+                </a:solidFill>
+                <a:effectLst/>
+                <a:latin typeface="Consolas" panose="020B0609020204030204" pitchFamily="49" charset="0"/>
+              </a:rPr>
+              <a:t>: {</a:t>
+            </a:r>
+          </a:p>
+          <a:p>
+            <a:r>
+              <a:rPr lang="en-GB" b="0" dirty="0">
+                <a:solidFill>
+                  <a:srgbClr val="CCCCCC"/>
+                </a:solidFill>
+                <a:effectLst/>
+                <a:latin typeface="Consolas" panose="020B0609020204030204" pitchFamily="49" charset="0"/>
+              </a:rPr>
+              <a:t>    </a:t>
+            </a:r>
+            <a:r>
+              <a:rPr lang="en-GB" b="0" dirty="0">
+                <a:solidFill>
+                  <a:srgbClr val="9CDCFE"/>
+                </a:solidFill>
+                <a:effectLst/>
+                <a:latin typeface="Consolas" panose="020B0609020204030204" pitchFamily="49" charset="0"/>
+              </a:rPr>
+              <a:t>"street"</a:t>
+            </a:r>
+            <a:r>
+              <a:rPr lang="en-GB" b="0" dirty="0">
+                <a:solidFill>
+                  <a:srgbClr val="CCCCCC"/>
+                </a:solidFill>
+                <a:effectLst/>
+                <a:latin typeface="Consolas" panose="020B0609020204030204" pitchFamily="49" charset="0"/>
+              </a:rPr>
+              <a:t>: </a:t>
+            </a:r>
+            <a:r>
+              <a:rPr lang="en-GB" b="0" dirty="0">
+                <a:solidFill>
+                  <a:srgbClr val="CE9178"/>
+                </a:solidFill>
+                <a:effectLst/>
+                <a:latin typeface="Consolas" panose="020B0609020204030204" pitchFamily="49" charset="0"/>
+              </a:rPr>
+              <a:t>"Tsar Boris III N61"</a:t>
+            </a:r>
+            <a:r>
+              <a:rPr lang="en-GB" b="0" dirty="0">
+                <a:solidFill>
+                  <a:srgbClr val="CCCCCC"/>
+                </a:solidFill>
+                <a:effectLst/>
+                <a:latin typeface="Consolas" panose="020B0609020204030204" pitchFamily="49" charset="0"/>
+              </a:rPr>
+              <a:t>,</a:t>
+            </a:r>
+          </a:p>
+          <a:p>
+            <a:r>
+              <a:rPr lang="en-GB" b="0" dirty="0">
+                <a:solidFill>
+                  <a:srgbClr val="CCCCCC"/>
+                </a:solidFill>
+                <a:effectLst/>
+                <a:latin typeface="Consolas" panose="020B0609020204030204" pitchFamily="49" charset="0"/>
+              </a:rPr>
+              <a:t>    </a:t>
+            </a:r>
+            <a:r>
+              <a:rPr lang="en-GB" b="0" dirty="0">
+                <a:solidFill>
+                  <a:srgbClr val="9CDCFE"/>
+                </a:solidFill>
+                <a:effectLst/>
+                <a:latin typeface="Consolas" panose="020B0609020204030204" pitchFamily="49" charset="0"/>
+              </a:rPr>
+              <a:t>"city"</a:t>
+            </a:r>
+            <a:r>
+              <a:rPr lang="en-GB" b="0" dirty="0">
+                <a:solidFill>
+                  <a:srgbClr val="CCCCCC"/>
+                </a:solidFill>
+                <a:effectLst/>
+                <a:latin typeface="Consolas" panose="020B0609020204030204" pitchFamily="49" charset="0"/>
+              </a:rPr>
+              <a:t>: </a:t>
+            </a:r>
+            <a:r>
+              <a:rPr lang="en-GB" b="0" dirty="0">
+                <a:solidFill>
+                  <a:srgbClr val="CE9178"/>
+                </a:solidFill>
+                <a:effectLst/>
+                <a:latin typeface="Consolas" panose="020B0609020204030204" pitchFamily="49" charset="0"/>
+              </a:rPr>
+              <a:t>"Sofia"</a:t>
+            </a:r>
+            <a:endParaRPr lang="en-GB" b="0" dirty="0">
+              <a:solidFill>
+                <a:srgbClr val="CCCCCC"/>
+              </a:solidFill>
+              <a:effectLst/>
+              <a:latin typeface="Consolas" panose="020B0609020204030204" pitchFamily="49" charset="0"/>
+            </a:endParaRPr>
+          </a:p>
+          <a:p>
+            <a:r>
+              <a:rPr lang="en-GB" b="0" dirty="0">
+                <a:solidFill>
+                  <a:srgbClr val="CCCCCC"/>
+                </a:solidFill>
+                <a:effectLst/>
+                <a:latin typeface="Consolas" panose="020B0609020204030204" pitchFamily="49" charset="0"/>
+              </a:rPr>
+              <a:t>  },</a:t>
+            </a:r>
+          </a:p>
+          <a:p>
+            <a:r>
+              <a:rPr lang="en-GB" b="0" dirty="0">
+                <a:solidFill>
+                  <a:srgbClr val="CCCCCC"/>
+                </a:solidFill>
+                <a:effectLst/>
+                <a:latin typeface="Consolas" panose="020B0609020204030204" pitchFamily="49" charset="0"/>
+              </a:rPr>
+              <a:t>  </a:t>
+            </a:r>
+            <a:r>
+              <a:rPr lang="en-GB" b="0" dirty="0">
+                <a:solidFill>
+                  <a:srgbClr val="9CDCFE"/>
+                </a:solidFill>
+                <a:effectLst/>
+                <a:latin typeface="Consolas" panose="020B0609020204030204" pitchFamily="49" charset="0"/>
+              </a:rPr>
+              <a:t>"</a:t>
+            </a:r>
+            <a:r>
+              <a:rPr lang="en-GB" b="0" dirty="0" err="1">
+                <a:solidFill>
+                  <a:srgbClr val="9CDCFE"/>
+                </a:solidFill>
+                <a:effectLst/>
+                <a:latin typeface="Consolas" panose="020B0609020204030204" pitchFamily="49" charset="0"/>
+              </a:rPr>
+              <a:t>favouriteSports</a:t>
+            </a:r>
+            <a:r>
+              <a:rPr lang="en-GB" b="0" dirty="0">
+                <a:solidFill>
+                  <a:srgbClr val="9CDCFE"/>
+                </a:solidFill>
+                <a:effectLst/>
+                <a:latin typeface="Consolas" panose="020B0609020204030204" pitchFamily="49" charset="0"/>
+              </a:rPr>
+              <a:t>"</a:t>
+            </a:r>
+            <a:r>
+              <a:rPr lang="en-GB" b="0" dirty="0">
+                <a:solidFill>
+                  <a:srgbClr val="CCCCCC"/>
+                </a:solidFill>
+                <a:effectLst/>
+                <a:latin typeface="Consolas" panose="020B0609020204030204" pitchFamily="49" charset="0"/>
+              </a:rPr>
+              <a:t> : [</a:t>
+            </a:r>
+            <a:r>
+              <a:rPr lang="en-GB" b="0" dirty="0">
+                <a:solidFill>
+                  <a:srgbClr val="CE9178"/>
+                </a:solidFill>
+                <a:effectLst/>
+                <a:latin typeface="Consolas" panose="020B0609020204030204" pitchFamily="49" charset="0"/>
+              </a:rPr>
+              <a:t>"Cycling"</a:t>
+            </a:r>
+            <a:r>
+              <a:rPr lang="en-GB" b="0" dirty="0">
+                <a:solidFill>
+                  <a:srgbClr val="CCCCCC"/>
+                </a:solidFill>
+                <a:effectLst/>
+                <a:latin typeface="Consolas" panose="020B0609020204030204" pitchFamily="49" charset="0"/>
+              </a:rPr>
+              <a:t>, </a:t>
+            </a:r>
+            <a:r>
+              <a:rPr lang="en-GB" b="0" dirty="0">
+                <a:solidFill>
+                  <a:srgbClr val="CE9178"/>
+                </a:solidFill>
+                <a:effectLst/>
+                <a:latin typeface="Consolas" panose="020B0609020204030204" pitchFamily="49" charset="0"/>
+              </a:rPr>
+              <a:t>"Running"</a:t>
+            </a:r>
+            <a:r>
+              <a:rPr lang="en-GB" b="0" dirty="0">
+                <a:solidFill>
+                  <a:srgbClr val="CCCCCC"/>
+                </a:solidFill>
+                <a:effectLst/>
+                <a:latin typeface="Consolas" panose="020B0609020204030204" pitchFamily="49" charset="0"/>
+              </a:rPr>
+              <a:t>]</a:t>
+            </a:r>
+          </a:p>
+          <a:p>
+            <a:r>
+              <a:rPr lang="en-GB" b="0" dirty="0">
+                <a:solidFill>
+                  <a:srgbClr val="CCCCCC"/>
+                </a:solidFill>
+                <a:effectLst/>
+                <a:latin typeface="Consolas" panose="020B0609020204030204" pitchFamily="49" charset="0"/>
+              </a:rPr>
+              <a:t>}</a:t>
+            </a:r>
+          </a:p>
+        </p:txBody>
+      </p:sp>
+      <p:sp>
+        <p:nvSpPr>
+          <p:cNvPr id="11" name="TextBox 10">
+            <a:extLst>
+              <a:ext uri="{FF2B5EF4-FFF2-40B4-BE49-F238E27FC236}">
+                <a16:creationId xmlns:a16="http://schemas.microsoft.com/office/drawing/2014/main" id="{630C7476-12B0-1EFF-DA4E-E29A8D53D468}"/>
+              </a:ext>
+            </a:extLst>
+          </p:cNvPr>
+          <p:cNvSpPr txBox="1"/>
+          <p:nvPr/>
+        </p:nvSpPr>
+        <p:spPr>
+          <a:xfrm>
+            <a:off x="7620000" y="2116515"/>
+            <a:ext cx="4093493" cy="2139047"/>
+          </a:xfrm>
+          <a:prstGeom prst="rect">
+            <a:avLst/>
+          </a:prstGeom>
+          <a:noFill/>
+        </p:spPr>
+        <p:txBody>
+          <a:bodyPr wrap="none" rtlCol="0">
+            <a:spAutoFit/>
+          </a:bodyPr>
+          <a:lstStyle/>
+          <a:p>
+            <a:pPr rtl="0" fontAlgn="base">
+              <a:spcBef>
+                <a:spcPts val="1000"/>
+              </a:spcBef>
+              <a:spcAft>
+                <a:spcPts val="0"/>
+              </a:spcAft>
+            </a:pPr>
+            <a:r>
+              <a:rPr lang="en-GB" sz="1800" b="0" i="0" u="none" strike="noStrike" dirty="0">
+                <a:solidFill>
+                  <a:srgbClr val="001E2B"/>
+                </a:solidFill>
+                <a:effectLst/>
+                <a:latin typeface="Lexend Deca" panose="020B0604020202020204" charset="0"/>
+              </a:rPr>
+              <a:t>JSON-based; Stored as BSON (binary </a:t>
+            </a:r>
+            <a:r>
+              <a:rPr lang="en-GB" sz="1800" b="0" i="0" u="none" strike="noStrike" dirty="0" err="1">
+                <a:solidFill>
+                  <a:srgbClr val="001E2B"/>
+                </a:solidFill>
+                <a:effectLst/>
+                <a:latin typeface="Lexend Deca" panose="020B0604020202020204" charset="0"/>
+              </a:rPr>
+              <a:t>json</a:t>
+            </a:r>
+            <a:r>
+              <a:rPr lang="en-GB" sz="1800" b="0" i="0" u="none" strike="noStrike" dirty="0">
+                <a:solidFill>
+                  <a:srgbClr val="001E2B"/>
+                </a:solidFill>
+                <a:effectLst/>
+                <a:latin typeface="Lexend Deca" panose="020B0604020202020204" charset="0"/>
+              </a:rPr>
+              <a:t>)</a:t>
+            </a:r>
+          </a:p>
+          <a:p>
+            <a:pPr rtl="0" fontAlgn="base">
+              <a:spcBef>
+                <a:spcPts val="1000"/>
+              </a:spcBef>
+              <a:spcAft>
+                <a:spcPts val="0"/>
+              </a:spcAft>
+            </a:pPr>
+            <a:r>
+              <a:rPr lang="en-GB" sz="1800" b="0" i="0" u="none" strike="noStrike" dirty="0">
+                <a:solidFill>
+                  <a:srgbClr val="001E2B"/>
+                </a:solidFill>
+                <a:effectLst/>
+                <a:latin typeface="Lexend Deca" panose="020B0604020202020204" charset="0"/>
+              </a:rPr>
+              <a:t>It is similar to Row (Record) in SQL</a:t>
+            </a:r>
+          </a:p>
+          <a:p>
+            <a:pPr rtl="0" fontAlgn="base">
+              <a:spcBef>
+                <a:spcPts val="1000"/>
+              </a:spcBef>
+              <a:spcAft>
+                <a:spcPts val="0"/>
+              </a:spcAft>
+            </a:pPr>
+            <a:r>
+              <a:rPr lang="en-GB" sz="1800" b="0" i="0" u="none" strike="noStrike" dirty="0">
+                <a:solidFill>
+                  <a:srgbClr val="001E2B"/>
+                </a:solidFill>
+                <a:effectLst/>
+                <a:latin typeface="Lexend Deca" panose="020B0604020202020204" charset="0"/>
+              </a:rPr>
+              <a:t>Consists of:</a:t>
+            </a:r>
+          </a:p>
+          <a:p>
+            <a:pPr marL="285750" indent="-285750" rtl="0" fontAlgn="base">
+              <a:spcBef>
+                <a:spcPts val="1000"/>
+              </a:spcBef>
+              <a:spcAft>
+                <a:spcPts val="0"/>
+              </a:spcAft>
+              <a:buFont typeface="Arial" panose="020B0604020202020204" pitchFamily="34" charset="0"/>
+              <a:buChar char="•"/>
+            </a:pPr>
+            <a:r>
+              <a:rPr lang="en-GB" sz="1800" b="0" i="0" u="none" strike="noStrike" dirty="0">
+                <a:solidFill>
+                  <a:srgbClr val="001E2B"/>
+                </a:solidFill>
+                <a:effectLst/>
+                <a:latin typeface="Lexend Deca" panose="020B0604020202020204" charset="0"/>
+              </a:rPr>
+              <a:t>Fields (Attributes)</a:t>
+            </a:r>
+          </a:p>
+          <a:p>
+            <a:pPr marL="285750" indent="-285750" rtl="0" fontAlgn="base">
+              <a:spcBef>
+                <a:spcPts val="0"/>
+              </a:spcBef>
+              <a:spcAft>
+                <a:spcPts val="0"/>
+              </a:spcAft>
+              <a:buFont typeface="Arial" panose="020B0604020202020204" pitchFamily="34" charset="0"/>
+              <a:buChar char="•"/>
+            </a:pPr>
+            <a:r>
+              <a:rPr lang="en-GB" sz="1800" b="0" i="0" u="none" strike="noStrike" dirty="0">
+                <a:solidFill>
+                  <a:srgbClr val="001E2B"/>
+                </a:solidFill>
+                <a:effectLst/>
+                <a:latin typeface="Lexend Deca" panose="020B0604020202020204" charset="0"/>
+              </a:rPr>
+              <a:t>Sub-documents (Objects)</a:t>
+            </a:r>
+          </a:p>
+          <a:p>
+            <a:pPr marL="285750" indent="-285750" rtl="0" fontAlgn="base">
+              <a:spcBef>
+                <a:spcPts val="0"/>
+              </a:spcBef>
+              <a:spcAft>
+                <a:spcPts val="1000"/>
+              </a:spcAft>
+              <a:buFont typeface="Arial" panose="020B0604020202020204" pitchFamily="34" charset="0"/>
+              <a:buChar char="•"/>
+            </a:pPr>
+            <a:r>
+              <a:rPr lang="en-GB" sz="1800" b="0" i="0" u="none" strike="noStrike" dirty="0">
+                <a:solidFill>
+                  <a:srgbClr val="001E2B"/>
+                </a:solidFill>
+                <a:effectLst/>
+                <a:latin typeface="Lexend Deca" panose="020B0604020202020204" charset="0"/>
+              </a:rPr>
+              <a:t>Arrays</a:t>
+            </a:r>
+          </a:p>
+        </p:txBody>
+      </p:sp>
+    </p:spTree>
+    <p:extLst>
+      <p:ext uri="{BB962C8B-B14F-4D97-AF65-F5344CB8AC3E}">
+        <p14:creationId xmlns:p14="http://schemas.microsoft.com/office/powerpoint/2010/main" val="1663318664"/>
+      </p:ext>
+    </p:extLst>
+  </p:cSld>
+  <p:clrMapOvr>
+    <a:masterClrMapping/>
+  </p:clrMapOvr>
+</p:sld>
+</file>
+
+<file path=ppt/slides/slide14.xml><?xml version="1.0" encoding="utf-8"?>
+<p:sld xmlns:a="http://schemas.openxmlformats.org/drawingml/2006/main" xmlns:r="http://schemas.openxmlformats.org/officeDocument/2006/relationships" xmlns:p="http://schemas.openxmlformats.org/presentationml/2006/main">
+  <p:cSld>
+    <p:spTree>
+      <p:nvGrpSpPr>
+        <p:cNvPr id="1" name=""/>
+        <p:cNvGrpSpPr/>
+        <p:nvPr/>
+      </p:nvGrpSpPr>
+      <p:grpSpPr>
+        <a:xfrm>
+          <a:off x="0" y="0"/>
+          <a:ext cx="0" cy="0"/>
+          <a:chOff x="0" y="0"/>
+          <a:chExt cx="0" cy="0"/>
+        </a:xfrm>
+      </p:grpSpPr>
+      <p:sp>
+        <p:nvSpPr>
+          <p:cNvPr id="2" name="Title 1">
+            <a:extLst>
+              <a:ext uri="{FF2B5EF4-FFF2-40B4-BE49-F238E27FC236}">
                 <a16:creationId xmlns:a16="http://schemas.microsoft.com/office/drawing/2014/main" id="{8B92BFED-02DB-605B-EB1F-41FE8F5F82E5}"/>
               </a:ext>
             </a:extLst>
@@ -6374,7 +6640,7 @@
 </p:sld>
 </file>
 
-<file path=ppt/slides/slide14.xml><?xml version="1.0" encoding="utf-8"?>
+<file path=ppt/slides/slide15.xml><?xml version="1.0" encoding="utf-8"?>
 <p:sld xmlns:a="http://schemas.openxmlformats.org/drawingml/2006/main" xmlns:r="http://schemas.openxmlformats.org/officeDocument/2006/relationships" xmlns:p="http://schemas.openxmlformats.org/presentationml/2006/main">
   <p:cSld>
     <p:spTree>
@@ -6490,70 +6756,6 @@
 </p:sld>
 </file>
 
-<file path=ppt/slides/slide15.xml><?xml version="1.0" encoding="utf-8"?>
-<p:sld xmlns:a="http://schemas.openxmlformats.org/drawingml/2006/main" xmlns:r="http://schemas.openxmlformats.org/officeDocument/2006/relationships" xmlns:p="http://schemas.openxmlformats.org/presentationml/2006/main">
-  <p:cSld>
-    <p:spTree>
-      <p:nvGrpSpPr>
-        <p:cNvPr id="1" name=""/>
-        <p:cNvGrpSpPr/>
-        <p:nvPr/>
-      </p:nvGrpSpPr>
-      <p:grpSpPr>
-        <a:xfrm>
-          <a:off x="0" y="0"/>
-          <a:ext cx="0" cy="0"/>
-          <a:chOff x="0" y="0"/>
-          <a:chExt cx="0" cy="0"/>
-        </a:xfrm>
-      </p:grpSpPr>
-      <p:sp>
-        <p:nvSpPr>
-          <p:cNvPr id="4" name="Title 1">
-            <a:extLst>
-              <a:ext uri="{FF2B5EF4-FFF2-40B4-BE49-F238E27FC236}">
-                <a16:creationId xmlns:a16="http://schemas.microsoft.com/office/drawing/2014/main" id="{C309BA76-E4FB-050C-659B-DC925767F144}"/>
-              </a:ext>
-            </a:extLst>
-          </p:cNvPr>
-          <p:cNvSpPr>
-            <a:spLocks noGrp="1"/>
-          </p:cNvSpPr>
-          <p:nvPr>
-            <p:ph type="title"/>
-          </p:nvPr>
-        </p:nvSpPr>
-        <p:spPr>
-          <a:xfrm>
-            <a:off x="838200" y="2766218"/>
-            <a:ext cx="10515600" cy="1325563"/>
-          </a:xfrm>
-        </p:spPr>
-        <p:txBody>
-          <a:bodyPr/>
-          <a:lstStyle/>
-          <a:p>
-            <a:pPr algn="ctr"/>
-            <a:r>
-              <a:rPr lang="en-GB" dirty="0"/>
-              <a:t>CRUD</a:t>
-            </a:r>
-          </a:p>
-        </p:txBody>
-      </p:sp>
-    </p:spTree>
-    <p:extLst>
-      <p:ext uri="{BB962C8B-B14F-4D97-AF65-F5344CB8AC3E}">
-        <p14:creationId xmlns:p14="http://schemas.microsoft.com/office/powerpoint/2010/main" val="1189805939"/>
-      </p:ext>
-    </p:extLst>
-  </p:cSld>
-  <p:clrMapOvr>
-    <a:masterClrMapping/>
-  </p:clrMapOvr>
-</p:sld>
-</file>
-
 <file path=ppt/slides/slide16.xml><?xml version="1.0" encoding="utf-8"?>
 <p:sld xmlns:a="http://schemas.openxmlformats.org/drawingml/2006/main" xmlns:r="http://schemas.openxmlformats.org/officeDocument/2006/relationships" xmlns:p="http://schemas.openxmlformats.org/presentationml/2006/main">
   <p:cSld>
@@ -6573,10 +6775,10 @@
       </p:grpSpPr>
       <p:sp>
         <p:nvSpPr>
-          <p:cNvPr id="2" name="Title 1">
-            <a:extLst>
-              <a:ext uri="{FF2B5EF4-FFF2-40B4-BE49-F238E27FC236}">
-                <a16:creationId xmlns:a16="http://schemas.microsoft.com/office/drawing/2014/main" id="{2DE73B78-62F1-29FF-9C93-78C7638B2C49}"/>
+          <p:cNvPr id="4" name="Title 1">
+            <a:extLst>
+              <a:ext uri="{FF2B5EF4-FFF2-40B4-BE49-F238E27FC236}">
+                <a16:creationId xmlns:a16="http://schemas.microsoft.com/office/drawing/2014/main" id="{C309BA76-E4FB-050C-659B-DC925767F144}"/>
               </a:ext>
             </a:extLst>
           </p:cNvPr>
@@ -6587,6 +6789,70 @@
             <p:ph type="title"/>
           </p:nvPr>
         </p:nvSpPr>
+        <p:spPr>
+          <a:xfrm>
+            <a:off x="838200" y="2766218"/>
+            <a:ext cx="10515600" cy="1325563"/>
+          </a:xfrm>
+        </p:spPr>
+        <p:txBody>
+          <a:bodyPr/>
+          <a:lstStyle/>
+          <a:p>
+            <a:pPr algn="ctr"/>
+            <a:r>
+              <a:rPr lang="en-GB" dirty="0"/>
+              <a:t>CRUD</a:t>
+            </a:r>
+          </a:p>
+        </p:txBody>
+      </p:sp>
+    </p:spTree>
+    <p:extLst>
+      <p:ext uri="{BB962C8B-B14F-4D97-AF65-F5344CB8AC3E}">
+        <p14:creationId xmlns:p14="http://schemas.microsoft.com/office/powerpoint/2010/main" val="1189805939"/>
+      </p:ext>
+    </p:extLst>
+  </p:cSld>
+  <p:clrMapOvr>
+    <a:masterClrMapping/>
+  </p:clrMapOvr>
+</p:sld>
+</file>
+
+<file path=ppt/slides/slide17.xml><?xml version="1.0" encoding="utf-8"?>
+<p:sld xmlns:a="http://schemas.openxmlformats.org/drawingml/2006/main" xmlns:r="http://schemas.openxmlformats.org/officeDocument/2006/relationships" xmlns:p="http://schemas.openxmlformats.org/presentationml/2006/main">
+  <p:cSld>
+    <p:spTree>
+      <p:nvGrpSpPr>
+        <p:cNvPr id="1" name=""/>
+        <p:cNvGrpSpPr/>
+        <p:nvPr/>
+      </p:nvGrpSpPr>
+      <p:grpSpPr>
+        <a:xfrm>
+          <a:off x="0" y="0"/>
+          <a:ext cx="0" cy="0"/>
+          <a:chOff x="0" y="0"/>
+          <a:chExt cx="0" cy="0"/>
+        </a:xfrm>
+      </p:grpSpPr>
+      <p:sp>
+        <p:nvSpPr>
+          <p:cNvPr id="2" name="Title 1">
+            <a:extLst>
+              <a:ext uri="{FF2B5EF4-FFF2-40B4-BE49-F238E27FC236}">
+                <a16:creationId xmlns:a16="http://schemas.microsoft.com/office/drawing/2014/main" id="{2DE73B78-62F1-29FF-9C93-78C7638B2C49}"/>
+              </a:ext>
+            </a:extLst>
+          </p:cNvPr>
+          <p:cNvSpPr>
+            <a:spLocks noGrp="1"/>
+          </p:cNvSpPr>
+          <p:nvPr>
+            <p:ph type="title"/>
+          </p:nvPr>
+        </p:nvSpPr>
         <p:spPr/>
         <p:txBody>
           <a:bodyPr/>
@@ -6674,7 +6940,7 @@
           <a:p>
             <a:r>
               <a:rPr lang="en-GB" dirty="0"/>
-              <a:t>options – non-mandatory. Specifies options for the operation</a:t>
+              <a:t>options – Optional. Specifies options for the operation</a:t>
             </a:r>
           </a:p>
         </p:txBody>
@@ -6722,7 +6988,7 @@
 </p:sld>
 </file>
 
-<file path=ppt/slides/slide17.xml><?xml version="1.0" encoding="utf-8"?>
+<file path=ppt/slides/slide18.xml><?xml version="1.0" encoding="utf-8"?>
 <p:sld xmlns:a="http://schemas.openxmlformats.org/drawingml/2006/main" xmlns:r="http://schemas.openxmlformats.org/officeDocument/2006/relationships" xmlns:p="http://schemas.openxmlformats.org/presentationml/2006/main">
   <p:cSld>
     <p:spTree>
@@ -7028,7 +7294,7 @@
           <a:p>
             <a:r>
               <a:rPr lang="en-GB" dirty="0"/>
-              <a:t>options – non-mandatory. Specifies options for the operation</a:t>
+              <a:t>options – Optional. Specifies options for the operation</a:t>
             </a:r>
           </a:p>
         </p:txBody>
@@ -7076,7 +7342,7 @@
 </p:sld>
 </file>
 
-<file path=ppt/slides/slide18.xml><?xml version="1.0" encoding="utf-8"?>
+<file path=ppt/slides/slide19.xml><?xml version="1.0" encoding="utf-8"?>
 <p:sld xmlns:a="http://schemas.openxmlformats.org/drawingml/2006/main" xmlns:r="http://schemas.openxmlformats.org/officeDocument/2006/relationships" xmlns:p="http://schemas.openxmlformats.org/presentationml/2006/main">
   <p:cSld>
     <p:spTree>
@@ -7178,7 +7444,7 @@
           <a:p>
             <a:r>
               <a:rPr lang="en-GB" dirty="0"/>
-              <a:t>projection – Document, which specifies which fields to be returned and which not.</a:t>
+              <a:t>projection – Optional. Document, which specifies which fields to be returned and which not.</a:t>
             </a:r>
           </a:p>
           <a:p>
@@ -7232,99 +7498,6 @@
 </p:sld>
 </file>
 
-<file path=ppt/slides/slide19.xml><?xml version="1.0" encoding="utf-8"?>
-<p:sld xmlns:a="http://schemas.openxmlformats.org/drawingml/2006/main" xmlns:r="http://schemas.openxmlformats.org/officeDocument/2006/relationships" xmlns:p="http://schemas.openxmlformats.org/presentationml/2006/main">
-  <p:cSld>
-    <p:spTree>
-      <p:nvGrpSpPr>
-        <p:cNvPr id="1" name=""/>
-        <p:cNvGrpSpPr/>
-        <p:nvPr/>
-      </p:nvGrpSpPr>
-      <p:grpSpPr>
-        <a:xfrm>
-          <a:off x="0" y="0"/>
-          <a:ext cx="0" cy="0"/>
-          <a:chOff x="0" y="0"/>
-          <a:chExt cx="0" cy="0"/>
-        </a:xfrm>
-      </p:grpSpPr>
-      <p:pic>
-        <p:nvPicPr>
-          <p:cNvPr id="5" name="Picture 4">
-            <a:extLst>
-              <a:ext uri="{FF2B5EF4-FFF2-40B4-BE49-F238E27FC236}">
-                <a16:creationId xmlns:a16="http://schemas.microsoft.com/office/drawing/2014/main" id="{6C4C02B1-D7C4-C46B-D1B7-9229AE00B90B}"/>
-              </a:ext>
-            </a:extLst>
-          </p:cNvPr>
-          <p:cNvPicPr>
-            <a:picLocks noChangeAspect="1"/>
-          </p:cNvPicPr>
-          <p:nvPr/>
-        </p:nvPicPr>
-        <p:blipFill>
-          <a:blip r:embed="rId2"/>
-          <a:stretch>
-            <a:fillRect/>
-          </a:stretch>
-        </p:blipFill>
-        <p:spPr>
-          <a:xfrm>
-            <a:off x="2852336" y="1995191"/>
-            <a:ext cx="5744377" cy="4239217"/>
-          </a:xfrm>
-          <a:prstGeom prst="rect">
-            <a:avLst/>
-          </a:prstGeom>
-        </p:spPr>
-      </p:pic>
-      <p:sp>
-        <p:nvSpPr>
-          <p:cNvPr id="6" name="Title 1">
-            <a:extLst>
-              <a:ext uri="{FF2B5EF4-FFF2-40B4-BE49-F238E27FC236}">
-                <a16:creationId xmlns:a16="http://schemas.microsoft.com/office/drawing/2014/main" id="{E904E1DE-7644-6575-9BC6-00C77A65F048}"/>
-              </a:ext>
-            </a:extLst>
-          </p:cNvPr>
-          <p:cNvSpPr>
-            <a:spLocks noGrp="1"/>
-          </p:cNvSpPr>
-          <p:nvPr>
-            <p:ph type="title"/>
-          </p:nvPr>
-        </p:nvSpPr>
-        <p:spPr>
-          <a:xfrm>
-            <a:off x="838200" y="365125"/>
-            <a:ext cx="10515600" cy="1325563"/>
-          </a:xfrm>
-        </p:spPr>
-        <p:txBody>
-          <a:bodyPr/>
-          <a:lstStyle/>
-          <a:p>
-            <a:r>
-              <a:rPr lang="en-GB" dirty="0"/>
-              <a:t>Read (find)</a:t>
-            </a:r>
-          </a:p>
-        </p:txBody>
-      </p:sp>
-    </p:spTree>
-    <p:extLst>
-      <p:ext uri="{BB962C8B-B14F-4D97-AF65-F5344CB8AC3E}">
-        <p14:creationId xmlns:p14="http://schemas.microsoft.com/office/powerpoint/2010/main" val="2258106957"/>
-      </p:ext>
-    </p:extLst>
-  </p:cSld>
-  <p:clrMapOvr>
-    <a:masterClrMapping/>
-  </p:clrMapOvr>
-</p:sld>
-</file>
-
 <file path=ppt/slides/slide2.xml><?xml version="1.0" encoding="utf-8"?>
 <p:sld xmlns:a="http://schemas.openxmlformats.org/drawingml/2006/main" xmlns:r="http://schemas.openxmlformats.org/officeDocument/2006/relationships" xmlns:p="http://schemas.openxmlformats.org/presentationml/2006/main">
   <p:cSld>
@@ -7347,7 +7520,7 @@
           <p:cNvPr id="2" name="Title 1">
             <a:extLst>
               <a:ext uri="{FF2B5EF4-FFF2-40B4-BE49-F238E27FC236}">
-                <a16:creationId xmlns:a16="http://schemas.microsoft.com/office/drawing/2014/main" id="{2DF2FDBA-355F-CFE6-F0EA-FCFA5341ACAE}"/>
+                <a16:creationId xmlns:a16="http://schemas.microsoft.com/office/drawing/2014/main" id="{3D97D480-80B4-7E59-5874-451606A1E25D}"/>
               </a:ext>
             </a:extLst>
           </p:cNvPr>
@@ -7355,7 +7528,7 @@
             <a:spLocks noGrp="1"/>
           </p:cNvSpPr>
           <p:nvPr>
-            <p:ph type="title"/>
+            <p:ph type="ctrTitle"/>
           </p:nvPr>
         </p:nvSpPr>
         <p:spPr/>
@@ -7365,40 +7538,15 @@
           <a:p>
             <a:r>
               <a:rPr lang="en-GB" dirty="0"/>
-              <a:t>Relational vs Non-Relational Model</a:t>
-            </a:r>
-          </a:p>
-        </p:txBody>
-      </p:sp>
-      <p:sp>
-        <p:nvSpPr>
-          <p:cNvPr id="3" name="Content Placeholder 2">
-            <a:extLst>
-              <a:ext uri="{FF2B5EF4-FFF2-40B4-BE49-F238E27FC236}">
-                <a16:creationId xmlns:a16="http://schemas.microsoft.com/office/drawing/2014/main" id="{41621D54-7A72-870D-5571-B90246632F31}"/>
-              </a:ext>
-            </a:extLst>
-          </p:cNvPr>
-          <p:cNvSpPr>
-            <a:spLocks noGrp="1"/>
-          </p:cNvSpPr>
-          <p:nvPr>
-            <p:ph idx="1"/>
-          </p:nvPr>
-        </p:nvSpPr>
-        <p:spPr/>
-        <p:txBody>
-          <a:bodyPr/>
-          <a:lstStyle/>
-          <a:p>
-            <a:endParaRPr lang="en-GB" dirty="0"/>
+              <a:t>MongoDB Basics</a:t>
+            </a:r>
           </a:p>
         </p:txBody>
       </p:sp>
     </p:spTree>
     <p:extLst>
       <p:ext uri="{BB962C8B-B14F-4D97-AF65-F5344CB8AC3E}">
-        <p14:creationId xmlns:p14="http://schemas.microsoft.com/office/powerpoint/2010/main" val="961389852"/>
+        <p14:creationId xmlns:p14="http://schemas.microsoft.com/office/powerpoint/2010/main" val="1434146520"/>
       </p:ext>
     </p:extLst>
   </p:cSld>
@@ -7425,6 +7573,99 @@
           <a:chExt cx="0" cy="0"/>
         </a:xfrm>
       </p:grpSpPr>
+      <p:pic>
+        <p:nvPicPr>
+          <p:cNvPr id="5" name="Picture 4">
+            <a:extLst>
+              <a:ext uri="{FF2B5EF4-FFF2-40B4-BE49-F238E27FC236}">
+                <a16:creationId xmlns:a16="http://schemas.microsoft.com/office/drawing/2014/main" id="{6C4C02B1-D7C4-C46B-D1B7-9229AE00B90B}"/>
+              </a:ext>
+            </a:extLst>
+          </p:cNvPr>
+          <p:cNvPicPr>
+            <a:picLocks noChangeAspect="1"/>
+          </p:cNvPicPr>
+          <p:nvPr/>
+        </p:nvPicPr>
+        <p:blipFill>
+          <a:blip r:embed="rId2"/>
+          <a:stretch>
+            <a:fillRect/>
+          </a:stretch>
+        </p:blipFill>
+        <p:spPr>
+          <a:xfrm>
+            <a:off x="2852336" y="1995191"/>
+            <a:ext cx="5744377" cy="4239217"/>
+          </a:xfrm>
+          <a:prstGeom prst="rect">
+            <a:avLst/>
+          </a:prstGeom>
+        </p:spPr>
+      </p:pic>
+      <p:sp>
+        <p:nvSpPr>
+          <p:cNvPr id="6" name="Title 1">
+            <a:extLst>
+              <a:ext uri="{FF2B5EF4-FFF2-40B4-BE49-F238E27FC236}">
+                <a16:creationId xmlns:a16="http://schemas.microsoft.com/office/drawing/2014/main" id="{E904E1DE-7644-6575-9BC6-00C77A65F048}"/>
+              </a:ext>
+            </a:extLst>
+          </p:cNvPr>
+          <p:cNvSpPr>
+            <a:spLocks noGrp="1"/>
+          </p:cNvSpPr>
+          <p:nvPr>
+            <p:ph type="title"/>
+          </p:nvPr>
+        </p:nvSpPr>
+        <p:spPr>
+          <a:xfrm>
+            <a:off x="838200" y="365125"/>
+            <a:ext cx="10515600" cy="1325563"/>
+          </a:xfrm>
+        </p:spPr>
+        <p:txBody>
+          <a:bodyPr/>
+          <a:lstStyle/>
+          <a:p>
+            <a:r>
+              <a:rPr lang="en-GB" dirty="0"/>
+              <a:t>Read (find)</a:t>
+            </a:r>
+          </a:p>
+        </p:txBody>
+      </p:sp>
+    </p:spTree>
+    <p:extLst>
+      <p:ext uri="{BB962C8B-B14F-4D97-AF65-F5344CB8AC3E}">
+        <p14:creationId xmlns:p14="http://schemas.microsoft.com/office/powerpoint/2010/main" val="2258106957"/>
+      </p:ext>
+    </p:extLst>
+  </p:cSld>
+  <p:clrMapOvr>
+    <a:masterClrMapping/>
+  </p:clrMapOvr>
+</p:sld>
+</file>
+
+<file path=ppt/slides/slide21.xml><?xml version="1.0" encoding="utf-8"?>
+<p:sld xmlns:a="http://schemas.openxmlformats.org/drawingml/2006/main" xmlns:r="http://schemas.openxmlformats.org/officeDocument/2006/relationships" xmlns:p="http://schemas.openxmlformats.org/presentationml/2006/main">
+  <p:cSld>
+    <p:spTree>
+      <p:nvGrpSpPr>
+        <p:cNvPr id="1" name=""/>
+        <p:cNvGrpSpPr/>
+        <p:nvPr/>
+      </p:nvGrpSpPr>
+      <p:grpSpPr>
+        <a:xfrm>
+          <a:off x="0" y="0"/>
+          <a:ext cx="0" cy="0"/>
+          <a:chOff x="0" y="0"/>
+          <a:chExt cx="0" cy="0"/>
+        </a:xfrm>
+      </p:grpSpPr>
       <p:sp>
         <p:nvSpPr>
           <p:cNvPr id="2" name="Title 1">
@@ -7570,8 +7811,8 @@
 </p:sld>
 </file>
 
-<file path=ppt/slides/slide21.xml><?xml version="1.0" encoding="utf-8"?>
-<p:sld xmlns:a="http://schemas.openxmlformats.org/drawingml/2006/main" xmlns:r="http://schemas.openxmlformats.org/officeDocument/2006/relationships" xmlns:p="http://schemas.openxmlformats.org/presentationml/2006/main">
+<file path=ppt/slides/slide22.xml><?xml version="1.0" encoding="utf-8"?>
+<p:sld xmlns:a="http://schemas.openxmlformats.org/drawingml/2006/main" xmlns:r="http://schemas.openxmlformats.org/officeDocument/2006/relationships" xmlns:p="http://schemas.openxmlformats.org/presentationml/2006/main" show="0">
   <p:cSld>
     <p:spTree>
       <p:nvGrpSpPr>
@@ -7702,7 +7943,7 @@
 </p:sld>
 </file>
 
-<file path=ppt/slides/slide22.xml><?xml version="1.0" encoding="utf-8"?>
+<file path=ppt/slides/slide23.xml><?xml version="1.0" encoding="utf-8"?>
 <p:sld xmlns:a="http://schemas.openxmlformats.org/drawingml/2006/main" xmlns:r="http://schemas.openxmlformats.org/officeDocument/2006/relationships" xmlns:p="http://schemas.openxmlformats.org/presentationml/2006/main">
   <p:cSld>
     <p:spTree>
@@ -7869,7 +8110,7 @@
 </p:sld>
 </file>
 
-<file path=ppt/slides/slide23.xml><?xml version="1.0" encoding="utf-8"?>
+<file path=ppt/slides/slide24.xml><?xml version="1.0" encoding="utf-8"?>
 <p:sld xmlns:a="http://schemas.openxmlformats.org/drawingml/2006/main" xmlns:r="http://schemas.openxmlformats.org/officeDocument/2006/relationships" xmlns:p="http://schemas.openxmlformats.org/presentationml/2006/main">
   <p:cSld>
     <p:spTree>
@@ -8033,7 +8274,7 @@
 </p:sld>
 </file>
 
-<file path=ppt/slides/slide24.xml><?xml version="1.0" encoding="utf-8"?>
+<file path=ppt/slides/slide25.xml><?xml version="1.0" encoding="utf-8"?>
 <p:sld xmlns:a="http://schemas.openxmlformats.org/drawingml/2006/main" xmlns:r="http://schemas.openxmlformats.org/officeDocument/2006/relationships" xmlns:p="http://schemas.openxmlformats.org/presentationml/2006/main">
   <p:cSld>
     <p:spTree>
@@ -8239,106 +8480,6 @@
     <p:extLst>
       <p:ext uri="{BB962C8B-B14F-4D97-AF65-F5344CB8AC3E}">
         <p14:creationId xmlns:p14="http://schemas.microsoft.com/office/powerpoint/2010/main" val="3829612164"/>
-      </p:ext>
-    </p:extLst>
-  </p:cSld>
-  <p:clrMapOvr>
-    <a:masterClrMapping/>
-  </p:clrMapOvr>
-</p:sld>
-</file>
-
-<file path=ppt/slides/slide25.xml><?xml version="1.0" encoding="utf-8"?>
-<p:sld xmlns:a="http://schemas.openxmlformats.org/drawingml/2006/main" xmlns:r="http://schemas.openxmlformats.org/officeDocument/2006/relationships" xmlns:p="http://schemas.openxmlformats.org/presentationml/2006/main">
-  <p:cSld>
-    <p:spTree>
-      <p:nvGrpSpPr>
-        <p:cNvPr id="1" name=""/>
-        <p:cNvGrpSpPr/>
-        <p:nvPr/>
-      </p:nvGrpSpPr>
-      <p:grpSpPr>
-        <a:xfrm>
-          <a:off x="0" y="0"/>
-          <a:ext cx="0" cy="0"/>
-          <a:chOff x="0" y="0"/>
-          <a:chExt cx="0" cy="0"/>
-        </a:xfrm>
-      </p:grpSpPr>
-      <p:sp>
-        <p:nvSpPr>
-          <p:cNvPr id="2" name="Title 1">
-            <a:extLst>
-              <a:ext uri="{FF2B5EF4-FFF2-40B4-BE49-F238E27FC236}">
-                <a16:creationId xmlns:a16="http://schemas.microsoft.com/office/drawing/2014/main" id="{A8EC1B86-F696-82CE-0B6B-343CB4BDA957}"/>
-              </a:ext>
-            </a:extLst>
-          </p:cNvPr>
-          <p:cNvSpPr>
-            <a:spLocks noGrp="1"/>
-          </p:cNvSpPr>
-          <p:nvPr>
-            <p:ph type="title"/>
-          </p:nvPr>
-        </p:nvSpPr>
-        <p:spPr/>
-        <p:txBody>
-          <a:bodyPr/>
-          <a:lstStyle/>
-          <a:p>
-            <a:r>
-              <a:rPr lang="en-GB" dirty="0"/>
-              <a:t>Other Important features</a:t>
-            </a:r>
-          </a:p>
-        </p:txBody>
-      </p:sp>
-      <p:sp>
-        <p:nvSpPr>
-          <p:cNvPr id="9" name="Content Placeholder 2">
-            <a:extLst>
-              <a:ext uri="{FF2B5EF4-FFF2-40B4-BE49-F238E27FC236}">
-                <a16:creationId xmlns:a16="http://schemas.microsoft.com/office/drawing/2014/main" id="{A4F4DFBC-9ECA-68DE-5615-6F15AA39A752}"/>
-              </a:ext>
-            </a:extLst>
-          </p:cNvPr>
-          <p:cNvSpPr>
-            <a:spLocks noGrp="1"/>
-          </p:cNvSpPr>
-          <p:nvPr>
-            <p:ph idx="1"/>
-          </p:nvPr>
-        </p:nvSpPr>
-        <p:spPr>
-          <a:xfrm>
-            <a:off x="838200" y="1825625"/>
-            <a:ext cx="11163300" cy="4351338"/>
-          </a:xfrm>
-        </p:spPr>
-        <p:txBody>
-          <a:bodyPr/>
-          <a:lstStyle/>
-          <a:p>
-            <a:r>
-              <a:rPr lang="en-GB" dirty="0"/>
-              <a:t>Indexes – Single field, Compound, Text, Geospatial, Unique, etc.</a:t>
-            </a:r>
-          </a:p>
-          <a:p>
-            <a:r>
-              <a:rPr lang="en-GB" dirty="0"/>
-              <a:t>Aggregation Framework.</a:t>
-            </a:r>
-          </a:p>
-          <a:p>
-            <a:endParaRPr lang="en-GB" dirty="0"/>
-          </a:p>
-        </p:txBody>
-      </p:sp>
-    </p:spTree>
-    <p:extLst>
-      <p:ext uri="{BB962C8B-B14F-4D97-AF65-F5344CB8AC3E}">
-        <p14:creationId xmlns:p14="http://schemas.microsoft.com/office/powerpoint/2010/main" val="3794063941"/>
       </p:ext>
     </p:extLst>
   </p:cSld>
@@ -8367,6 +8508,106 @@
       </p:grpSpPr>
       <p:sp>
         <p:nvSpPr>
+          <p:cNvPr id="2" name="Title 1">
+            <a:extLst>
+              <a:ext uri="{FF2B5EF4-FFF2-40B4-BE49-F238E27FC236}">
+                <a16:creationId xmlns:a16="http://schemas.microsoft.com/office/drawing/2014/main" id="{A8EC1B86-F696-82CE-0B6B-343CB4BDA957}"/>
+              </a:ext>
+            </a:extLst>
+          </p:cNvPr>
+          <p:cNvSpPr>
+            <a:spLocks noGrp="1"/>
+          </p:cNvSpPr>
+          <p:nvPr>
+            <p:ph type="title"/>
+          </p:nvPr>
+        </p:nvSpPr>
+        <p:spPr/>
+        <p:txBody>
+          <a:bodyPr/>
+          <a:lstStyle/>
+          <a:p>
+            <a:r>
+              <a:rPr lang="en-GB" dirty="0"/>
+              <a:t>Other Important features</a:t>
+            </a:r>
+          </a:p>
+        </p:txBody>
+      </p:sp>
+      <p:sp>
+        <p:nvSpPr>
+          <p:cNvPr id="9" name="Content Placeholder 2">
+            <a:extLst>
+              <a:ext uri="{FF2B5EF4-FFF2-40B4-BE49-F238E27FC236}">
+                <a16:creationId xmlns:a16="http://schemas.microsoft.com/office/drawing/2014/main" id="{A4F4DFBC-9ECA-68DE-5615-6F15AA39A752}"/>
+              </a:ext>
+            </a:extLst>
+          </p:cNvPr>
+          <p:cNvSpPr>
+            <a:spLocks noGrp="1"/>
+          </p:cNvSpPr>
+          <p:nvPr>
+            <p:ph idx="1"/>
+          </p:nvPr>
+        </p:nvSpPr>
+        <p:spPr>
+          <a:xfrm>
+            <a:off x="838200" y="1825625"/>
+            <a:ext cx="11163300" cy="4351338"/>
+          </a:xfrm>
+        </p:spPr>
+        <p:txBody>
+          <a:bodyPr/>
+          <a:lstStyle/>
+          <a:p>
+            <a:r>
+              <a:rPr lang="en-GB" dirty="0"/>
+              <a:t>Indexes – Single field, Compound, Text, Geospatial, Unique, etc.</a:t>
+            </a:r>
+          </a:p>
+          <a:p>
+            <a:r>
+              <a:rPr lang="en-GB" dirty="0"/>
+              <a:t>Aggregation Framework.</a:t>
+            </a:r>
+          </a:p>
+          <a:p>
+            <a:endParaRPr lang="en-GB" dirty="0"/>
+          </a:p>
+        </p:txBody>
+      </p:sp>
+    </p:spTree>
+    <p:extLst>
+      <p:ext uri="{BB962C8B-B14F-4D97-AF65-F5344CB8AC3E}">
+        <p14:creationId xmlns:p14="http://schemas.microsoft.com/office/powerpoint/2010/main" val="3794063941"/>
+      </p:ext>
+    </p:extLst>
+  </p:cSld>
+  <p:clrMapOvr>
+    <a:masterClrMapping/>
+  </p:clrMapOvr>
+</p:sld>
+</file>
+
+<file path=ppt/slides/slide27.xml><?xml version="1.0" encoding="utf-8"?>
+<p:sld xmlns:a="http://schemas.openxmlformats.org/drawingml/2006/main" xmlns:r="http://schemas.openxmlformats.org/officeDocument/2006/relationships" xmlns:p="http://schemas.openxmlformats.org/presentationml/2006/main">
+  <p:cSld>
+    <p:spTree>
+      <p:nvGrpSpPr>
+        <p:cNvPr id="1" name=""/>
+        <p:cNvGrpSpPr/>
+        <p:nvPr/>
+      </p:nvGrpSpPr>
+      <p:grpSpPr>
+        <a:xfrm>
+          <a:off x="0" y="0"/>
+          <a:ext cx="0" cy="0"/>
+          <a:chOff x="0" y="0"/>
+          <a:chExt cx="0" cy="0"/>
+        </a:xfrm>
+      </p:grpSpPr>
+      <p:sp>
+        <p:nvSpPr>
           <p:cNvPr id="4" name="Title 1">
             <a:extLst>
               <a:ext uri="{FF2B5EF4-FFF2-40B4-BE49-F238E27FC236}">
@@ -8433,7 +8674,7 @@
 </p:sld>
 </file>
 
-<file path=ppt/slides/slide27.xml><?xml version="1.0" encoding="utf-8"?>
+<file path=ppt/slides/slide28.xml><?xml version="1.0" encoding="utf-8"?>
 <p:sld xmlns:a="http://schemas.openxmlformats.org/drawingml/2006/main" xmlns:r="http://schemas.openxmlformats.org/officeDocument/2006/relationships" xmlns:p="http://schemas.openxmlformats.org/presentationml/2006/main">
   <p:cSld>
     <p:spTree>
@@ -10077,1074 +10318,178 @@
   <p:clrMapOvr>
     <a:masterClrMapping/>
   </p:clrMapOvr>
-  <p:timing>
-    <p:tnLst>
-      <p:par>
-        <p:cTn id="1" dur="indefinite" restart="never" nodeType="tmRoot">
-          <p:childTnLst>
-            <p:seq concurrent="1" nextAc="seek">
-              <p:cTn id="2" dur="indefinite" nodeType="mainSeq">
-                <p:childTnLst>
-                  <p:par>
-                    <p:cTn id="3" fill="hold">
-                      <p:stCondLst>
-                        <p:cond delay="indefinite"/>
-                      </p:stCondLst>
-                      <p:childTnLst>
-                        <p:par>
-                          <p:cTn id="4" fill="hold">
-                            <p:stCondLst>
-                              <p:cond delay="0"/>
-                            </p:stCondLst>
-                            <p:childTnLst>
-                              <p:par>
-                                <p:cTn id="5" presetID="10" presetClass="entr" presetSubtype="0" fill="hold" nodeType="clickEffect">
-                                  <p:stCondLst>
-                                    <p:cond delay="0"/>
-                                  </p:stCondLst>
-                                  <p:childTnLst>
-                                    <p:set>
-                                      <p:cBhvr>
-                                        <p:cTn id="6" dur="1" fill="hold">
-                                          <p:stCondLst>
-                                            <p:cond delay="0"/>
-                                          </p:stCondLst>
-                                        </p:cTn>
-                                        <p:tgtEl>
-                                          <p:spTgt spid="3603"/>
-                                        </p:tgtEl>
-                                        <p:attrNameLst>
-                                          <p:attrName>style.visibility</p:attrName>
-                                        </p:attrNameLst>
-                                      </p:cBhvr>
-                                      <p:to>
-                                        <p:strVal val="visible"/>
-                                      </p:to>
-                                    </p:set>
-                                    <p:animEffect transition="in" filter="fade">
-                                      <p:cBhvr>
-                                        <p:cTn id="7" dur="1000"/>
-                                        <p:tgtEl>
-                                          <p:spTgt spid="3603"/>
-                                        </p:tgtEl>
-                                      </p:cBhvr>
-                                    </p:animEffect>
-                                  </p:childTnLst>
-                                </p:cTn>
-                              </p:par>
-                              <p:par>
-                                <p:cTn id="8" presetID="10" presetClass="entr" presetSubtype="0" fill="hold" nodeType="withEffect">
-                                  <p:stCondLst>
-                                    <p:cond delay="0"/>
-                                  </p:stCondLst>
-                                  <p:childTnLst>
-                                    <p:set>
-                                      <p:cBhvr>
-                                        <p:cTn id="9" dur="1" fill="hold">
-                                          <p:stCondLst>
-                                            <p:cond delay="0"/>
-                                          </p:stCondLst>
-                                        </p:cTn>
-                                        <p:tgtEl>
-                                          <p:spTgt spid="3604"/>
-                                        </p:tgtEl>
-                                        <p:attrNameLst>
-                                          <p:attrName>style.visibility</p:attrName>
-                                        </p:attrNameLst>
-                                      </p:cBhvr>
-                                      <p:to>
-                                        <p:strVal val="visible"/>
-                                      </p:to>
-                                    </p:set>
-                                    <p:animEffect transition="in" filter="fade">
-                                      <p:cBhvr>
-                                        <p:cTn id="10" dur="1000"/>
-                                        <p:tgtEl>
-                                          <p:spTgt spid="3604"/>
-                                        </p:tgtEl>
-                                      </p:cBhvr>
-                                    </p:animEffect>
-                                  </p:childTnLst>
-                                </p:cTn>
-                              </p:par>
-                              <p:par>
-                                <p:cTn id="11" presetID="10" presetClass="entr" presetSubtype="0" fill="hold" nodeType="withEffect">
-                                  <p:stCondLst>
-                                    <p:cond delay="0"/>
-                                  </p:stCondLst>
-                                  <p:childTnLst>
-                                    <p:set>
-                                      <p:cBhvr>
-                                        <p:cTn id="12" dur="1" fill="hold">
-                                          <p:stCondLst>
-                                            <p:cond delay="0"/>
-                                          </p:stCondLst>
-                                        </p:cTn>
-                                        <p:tgtEl>
-                                          <p:spTgt spid="3605"/>
-                                        </p:tgtEl>
-                                        <p:attrNameLst>
-                                          <p:attrName>style.visibility</p:attrName>
-                                        </p:attrNameLst>
-                                      </p:cBhvr>
-                                      <p:to>
-                                        <p:strVal val="visible"/>
-                                      </p:to>
-                                    </p:set>
-                                    <p:animEffect transition="in" filter="fade">
-                                      <p:cBhvr>
-                                        <p:cTn id="13" dur="1000"/>
-                                        <p:tgtEl>
-                                          <p:spTgt spid="3605"/>
-                                        </p:tgtEl>
-                                      </p:cBhvr>
-                                    </p:animEffect>
-                                  </p:childTnLst>
-                                </p:cTn>
-                              </p:par>
-                              <p:par>
-                                <p:cTn id="14" presetID="10" presetClass="entr" presetSubtype="0" fill="hold" nodeType="withEffect">
-                                  <p:stCondLst>
-                                    <p:cond delay="0"/>
-                                  </p:stCondLst>
-                                  <p:childTnLst>
-                                    <p:set>
-                                      <p:cBhvr>
-                                        <p:cTn id="15" dur="1" fill="hold">
-                                          <p:stCondLst>
-                                            <p:cond delay="0"/>
-                                          </p:stCondLst>
-                                        </p:cTn>
-                                        <p:tgtEl>
-                                          <p:spTgt spid="3606"/>
-                                        </p:tgtEl>
-                                        <p:attrNameLst>
-                                          <p:attrName>style.visibility</p:attrName>
-                                        </p:attrNameLst>
-                                      </p:cBhvr>
-                                      <p:to>
-                                        <p:strVal val="visible"/>
-                                      </p:to>
-                                    </p:set>
-                                    <p:animEffect transition="in" filter="fade">
-                                      <p:cBhvr>
-                                        <p:cTn id="16" dur="1000"/>
-                                        <p:tgtEl>
-                                          <p:spTgt spid="3606"/>
-                                        </p:tgtEl>
-                                      </p:cBhvr>
-                                    </p:animEffect>
-                                  </p:childTnLst>
-                                </p:cTn>
-                              </p:par>
-                              <p:par>
-                                <p:cTn id="17" presetID="10" presetClass="entr" presetSubtype="0" fill="hold" nodeType="withEffect">
-                                  <p:stCondLst>
-                                    <p:cond delay="0"/>
-                                  </p:stCondLst>
-                                  <p:childTnLst>
-                                    <p:set>
-                                      <p:cBhvr>
-                                        <p:cTn id="18" dur="1" fill="hold">
-                                          <p:stCondLst>
-                                            <p:cond delay="0"/>
-                                          </p:stCondLst>
-                                        </p:cTn>
-                                        <p:tgtEl>
-                                          <p:spTgt spid="3607"/>
-                                        </p:tgtEl>
-                                        <p:attrNameLst>
-                                          <p:attrName>style.visibility</p:attrName>
-                                        </p:attrNameLst>
-                                      </p:cBhvr>
-                                      <p:to>
-                                        <p:strVal val="visible"/>
-                                      </p:to>
-                                    </p:set>
-                                    <p:animEffect transition="in" filter="fade">
-                                      <p:cBhvr>
-                                        <p:cTn id="19" dur="1000"/>
-                                        <p:tgtEl>
-                                          <p:spTgt spid="3607"/>
-                                        </p:tgtEl>
-                                      </p:cBhvr>
-                                    </p:animEffect>
-                                  </p:childTnLst>
-                                </p:cTn>
-                              </p:par>
-                              <p:par>
-                                <p:cTn id="20" presetID="10" presetClass="entr" presetSubtype="0" fill="hold" nodeType="withEffect">
-                                  <p:stCondLst>
-                                    <p:cond delay="0"/>
-                                  </p:stCondLst>
-                                  <p:childTnLst>
-                                    <p:set>
-                                      <p:cBhvr>
-                                        <p:cTn id="21" dur="1" fill="hold">
-                                          <p:stCondLst>
-                                            <p:cond delay="0"/>
-                                          </p:stCondLst>
-                                        </p:cTn>
-                                        <p:tgtEl>
-                                          <p:spTgt spid="3608"/>
-                                        </p:tgtEl>
-                                        <p:attrNameLst>
-                                          <p:attrName>style.visibility</p:attrName>
-                                        </p:attrNameLst>
-                                      </p:cBhvr>
-                                      <p:to>
-                                        <p:strVal val="visible"/>
-                                      </p:to>
-                                    </p:set>
-                                    <p:animEffect transition="in" filter="fade">
-                                      <p:cBhvr>
-                                        <p:cTn id="22" dur="1000"/>
-                                        <p:tgtEl>
-                                          <p:spTgt spid="3608"/>
-                                        </p:tgtEl>
-                                      </p:cBhvr>
-                                    </p:animEffect>
-                                  </p:childTnLst>
-                                </p:cTn>
-                              </p:par>
-                              <p:par>
-                                <p:cTn id="23" presetID="10" presetClass="entr" presetSubtype="0" fill="hold" nodeType="withEffect">
-                                  <p:stCondLst>
-                                    <p:cond delay="0"/>
-                                  </p:stCondLst>
-                                  <p:childTnLst>
-                                    <p:set>
-                                      <p:cBhvr>
-                                        <p:cTn id="24" dur="1" fill="hold">
-                                          <p:stCondLst>
-                                            <p:cond delay="0"/>
-                                          </p:stCondLst>
-                                        </p:cTn>
-                                        <p:tgtEl>
-                                          <p:spTgt spid="3609"/>
-                                        </p:tgtEl>
-                                        <p:attrNameLst>
-                                          <p:attrName>style.visibility</p:attrName>
-                                        </p:attrNameLst>
-                                      </p:cBhvr>
-                                      <p:to>
-                                        <p:strVal val="visible"/>
-                                      </p:to>
-                                    </p:set>
-                                    <p:animEffect transition="in" filter="fade">
-                                      <p:cBhvr>
-                                        <p:cTn id="25" dur="1000"/>
-                                        <p:tgtEl>
-                                          <p:spTgt spid="3609"/>
-                                        </p:tgtEl>
-                                      </p:cBhvr>
-                                    </p:animEffect>
-                                  </p:childTnLst>
-                                </p:cTn>
-                              </p:par>
-                              <p:par>
-                                <p:cTn id="26" presetID="10" presetClass="entr" presetSubtype="0" fill="hold" nodeType="withEffect">
-                                  <p:stCondLst>
-                                    <p:cond delay="0"/>
-                                  </p:stCondLst>
-                                  <p:childTnLst>
-                                    <p:set>
-                                      <p:cBhvr>
-                                        <p:cTn id="27" dur="1" fill="hold">
-                                          <p:stCondLst>
-                                            <p:cond delay="0"/>
-                                          </p:stCondLst>
-                                        </p:cTn>
-                                        <p:tgtEl>
-                                          <p:spTgt spid="3610"/>
-                                        </p:tgtEl>
-                                        <p:attrNameLst>
-                                          <p:attrName>style.visibility</p:attrName>
-                                        </p:attrNameLst>
-                                      </p:cBhvr>
-                                      <p:to>
-                                        <p:strVal val="visible"/>
-                                      </p:to>
-                                    </p:set>
-                                    <p:animEffect transition="in" filter="fade">
-                                      <p:cBhvr>
-                                        <p:cTn id="28" dur="1000"/>
-                                        <p:tgtEl>
-                                          <p:spTgt spid="3610"/>
-                                        </p:tgtEl>
-                                      </p:cBhvr>
-                                    </p:animEffect>
-                                  </p:childTnLst>
-                                </p:cTn>
-                              </p:par>
-                              <p:par>
-                                <p:cTn id="29" presetID="10" presetClass="entr" presetSubtype="0" fill="hold" nodeType="withEffect">
-                                  <p:stCondLst>
-                                    <p:cond delay="0"/>
-                                  </p:stCondLst>
-                                  <p:childTnLst>
-                                    <p:set>
-                                      <p:cBhvr>
-                                        <p:cTn id="30" dur="1" fill="hold">
-                                          <p:stCondLst>
-                                            <p:cond delay="0"/>
-                                          </p:stCondLst>
-                                        </p:cTn>
-                                        <p:tgtEl>
-                                          <p:spTgt spid="3611"/>
-                                        </p:tgtEl>
-                                        <p:attrNameLst>
-                                          <p:attrName>style.visibility</p:attrName>
-                                        </p:attrNameLst>
-                                      </p:cBhvr>
-                                      <p:to>
-                                        <p:strVal val="visible"/>
-                                      </p:to>
-                                    </p:set>
-                                    <p:animEffect transition="in" filter="fade">
-                                      <p:cBhvr>
-                                        <p:cTn id="31" dur="1000"/>
-                                        <p:tgtEl>
-                                          <p:spTgt spid="3611"/>
-                                        </p:tgtEl>
-                                      </p:cBhvr>
-                                    </p:animEffect>
-                                  </p:childTnLst>
-                                </p:cTn>
-                              </p:par>
-                              <p:par>
-                                <p:cTn id="32" presetID="10" presetClass="entr" presetSubtype="0" fill="hold" nodeType="withEffect">
-                                  <p:stCondLst>
-                                    <p:cond delay="0"/>
-                                  </p:stCondLst>
-                                  <p:childTnLst>
-                                    <p:set>
-                                      <p:cBhvr>
-                                        <p:cTn id="33" dur="1" fill="hold">
-                                          <p:stCondLst>
-                                            <p:cond delay="0"/>
-                                          </p:stCondLst>
-                                        </p:cTn>
-                                        <p:tgtEl>
-                                          <p:spTgt spid="3612"/>
-                                        </p:tgtEl>
-                                        <p:attrNameLst>
-                                          <p:attrName>style.visibility</p:attrName>
-                                        </p:attrNameLst>
-                                      </p:cBhvr>
-                                      <p:to>
-                                        <p:strVal val="visible"/>
-                                      </p:to>
-                                    </p:set>
-                                    <p:animEffect transition="in" filter="fade">
-                                      <p:cBhvr>
-                                        <p:cTn id="34" dur="1000"/>
-                                        <p:tgtEl>
-                                          <p:spTgt spid="3612"/>
-                                        </p:tgtEl>
-                                      </p:cBhvr>
-                                    </p:animEffect>
-                                  </p:childTnLst>
-                                </p:cTn>
-                              </p:par>
-                              <p:par>
-                                <p:cTn id="35" presetID="10" presetClass="entr" presetSubtype="0" fill="hold" nodeType="withEffect">
-                                  <p:stCondLst>
-                                    <p:cond delay="0"/>
-                                  </p:stCondLst>
-                                  <p:childTnLst>
-                                    <p:set>
-                                      <p:cBhvr>
-                                        <p:cTn id="36" dur="1" fill="hold">
-                                          <p:stCondLst>
-                                            <p:cond delay="0"/>
-                                          </p:stCondLst>
-                                        </p:cTn>
-                                        <p:tgtEl>
-                                          <p:spTgt spid="3613"/>
-                                        </p:tgtEl>
-                                        <p:attrNameLst>
-                                          <p:attrName>style.visibility</p:attrName>
-                                        </p:attrNameLst>
-                                      </p:cBhvr>
-                                      <p:to>
-                                        <p:strVal val="visible"/>
-                                      </p:to>
-                                    </p:set>
-                                    <p:animEffect transition="in" filter="fade">
-                                      <p:cBhvr>
-                                        <p:cTn id="37" dur="1000"/>
-                                        <p:tgtEl>
-                                          <p:spTgt spid="3613"/>
-                                        </p:tgtEl>
-                                      </p:cBhvr>
-                                    </p:animEffect>
-                                  </p:childTnLst>
-                                </p:cTn>
-                              </p:par>
-                              <p:par>
-                                <p:cTn id="38" presetID="10" presetClass="entr" presetSubtype="0" fill="hold" nodeType="withEffect">
-                                  <p:stCondLst>
-                                    <p:cond delay="0"/>
-                                  </p:stCondLst>
-                                  <p:childTnLst>
-                                    <p:set>
-                                      <p:cBhvr>
-                                        <p:cTn id="39" dur="1" fill="hold">
-                                          <p:stCondLst>
-                                            <p:cond delay="0"/>
-                                          </p:stCondLst>
-                                        </p:cTn>
-                                        <p:tgtEl>
-                                          <p:spTgt spid="3614"/>
-                                        </p:tgtEl>
-                                        <p:attrNameLst>
-                                          <p:attrName>style.visibility</p:attrName>
-                                        </p:attrNameLst>
-                                      </p:cBhvr>
-                                      <p:to>
-                                        <p:strVal val="visible"/>
-                                      </p:to>
-                                    </p:set>
-                                    <p:animEffect transition="in" filter="fade">
-                                      <p:cBhvr>
-                                        <p:cTn id="40" dur="1000"/>
-                                        <p:tgtEl>
-                                          <p:spTgt spid="3614"/>
-                                        </p:tgtEl>
-                                      </p:cBhvr>
-                                    </p:animEffect>
-                                  </p:childTnLst>
-                                </p:cTn>
-                              </p:par>
-                              <p:par>
-                                <p:cTn id="41" presetID="10" presetClass="entr" presetSubtype="0" fill="hold" nodeType="withEffect">
-                                  <p:stCondLst>
-                                    <p:cond delay="0"/>
-                                  </p:stCondLst>
-                                  <p:childTnLst>
-                                    <p:set>
-                                      <p:cBhvr>
-                                        <p:cTn id="42" dur="1" fill="hold">
-                                          <p:stCondLst>
-                                            <p:cond delay="0"/>
-                                          </p:stCondLst>
-                                        </p:cTn>
-                                        <p:tgtEl>
-                                          <p:spTgt spid="3618"/>
-                                        </p:tgtEl>
-                                        <p:attrNameLst>
-                                          <p:attrName>style.visibility</p:attrName>
-                                        </p:attrNameLst>
-                                      </p:cBhvr>
-                                      <p:to>
-                                        <p:strVal val="visible"/>
-                                      </p:to>
-                                    </p:set>
-                                    <p:animEffect transition="in" filter="fade">
-                                      <p:cBhvr>
-                                        <p:cTn id="43" dur="1000"/>
-                                        <p:tgtEl>
-                                          <p:spTgt spid="3618"/>
-                                        </p:tgtEl>
-                                      </p:cBhvr>
-                                    </p:animEffect>
-                                  </p:childTnLst>
-                                </p:cTn>
-                              </p:par>
-                            </p:childTnLst>
-                          </p:cTn>
-                        </p:par>
-                      </p:childTnLst>
-                    </p:cTn>
-                  </p:par>
-                  <p:par>
-                    <p:cTn id="44" fill="hold">
-                      <p:stCondLst>
-                        <p:cond delay="indefinite"/>
-                      </p:stCondLst>
-                      <p:childTnLst>
-                        <p:par>
-                          <p:cTn id="45" fill="hold">
-                            <p:stCondLst>
-                              <p:cond delay="0"/>
-                            </p:stCondLst>
-                            <p:childTnLst>
-                              <p:par>
-                                <p:cTn id="46" presetID="10" presetClass="entr" presetSubtype="0" fill="hold" nodeType="clickEffect">
-                                  <p:stCondLst>
-                                    <p:cond delay="0"/>
-                                  </p:stCondLst>
-                                  <p:childTnLst>
-                                    <p:set>
-                                      <p:cBhvr>
-                                        <p:cTn id="47" dur="1" fill="hold">
-                                          <p:stCondLst>
-                                            <p:cond delay="0"/>
-                                          </p:stCondLst>
-                                        </p:cTn>
-                                        <p:tgtEl>
-                                          <p:spTgt spid="3602"/>
-                                        </p:tgtEl>
-                                        <p:attrNameLst>
-                                          <p:attrName>style.visibility</p:attrName>
-                                        </p:attrNameLst>
-                                      </p:cBhvr>
-                                      <p:to>
-                                        <p:strVal val="visible"/>
-                                      </p:to>
-                                    </p:set>
-                                    <p:animEffect transition="in" filter="fade">
-                                      <p:cBhvr>
-                                        <p:cTn id="48" dur="1000"/>
-                                        <p:tgtEl>
-                                          <p:spTgt spid="3602"/>
-                                        </p:tgtEl>
-                                      </p:cBhvr>
-                                    </p:animEffect>
-                                  </p:childTnLst>
-                                </p:cTn>
-                              </p:par>
-                              <p:par>
-                                <p:cTn id="49" presetID="10" presetClass="entr" presetSubtype="0" fill="hold" nodeType="withEffect">
-                                  <p:stCondLst>
-                                    <p:cond delay="0"/>
-                                  </p:stCondLst>
-                                  <p:childTnLst>
-                                    <p:set>
-                                      <p:cBhvr>
-                                        <p:cTn id="50" dur="1" fill="hold">
-                                          <p:stCondLst>
-                                            <p:cond delay="0"/>
-                                          </p:stCondLst>
-                                        </p:cTn>
-                                        <p:tgtEl>
-                                          <p:spTgt spid="3615"/>
-                                        </p:tgtEl>
-                                        <p:attrNameLst>
-                                          <p:attrName>style.visibility</p:attrName>
-                                        </p:attrNameLst>
-                                      </p:cBhvr>
-                                      <p:to>
-                                        <p:strVal val="visible"/>
-                                      </p:to>
-                                    </p:set>
-                                    <p:animEffect transition="in" filter="fade">
-                                      <p:cBhvr>
-                                        <p:cTn id="51" dur="1000"/>
-                                        <p:tgtEl>
-                                          <p:spTgt spid="3615"/>
-                                        </p:tgtEl>
-                                      </p:cBhvr>
-                                    </p:animEffect>
-                                  </p:childTnLst>
-                                </p:cTn>
-                              </p:par>
-                              <p:par>
-                                <p:cTn id="52" presetID="10" presetClass="entr" presetSubtype="0" fill="hold" nodeType="withEffect">
-                                  <p:stCondLst>
-                                    <p:cond delay="0"/>
-                                  </p:stCondLst>
-                                  <p:childTnLst>
-                                    <p:set>
-                                      <p:cBhvr>
-                                        <p:cTn id="53" dur="1" fill="hold">
-                                          <p:stCondLst>
-                                            <p:cond delay="0"/>
-                                          </p:stCondLst>
-                                        </p:cTn>
-                                        <p:tgtEl>
-                                          <p:spTgt spid="3616"/>
-                                        </p:tgtEl>
-                                        <p:attrNameLst>
-                                          <p:attrName>style.visibility</p:attrName>
-                                        </p:attrNameLst>
-                                      </p:cBhvr>
-                                      <p:to>
-                                        <p:strVal val="visible"/>
-                                      </p:to>
-                                    </p:set>
-                                    <p:animEffect transition="in" filter="fade">
-                                      <p:cBhvr>
-                                        <p:cTn id="54" dur="1000"/>
-                                        <p:tgtEl>
-                                          <p:spTgt spid="3616"/>
-                                        </p:tgtEl>
-                                      </p:cBhvr>
-                                    </p:animEffect>
-                                  </p:childTnLst>
-                                </p:cTn>
-                              </p:par>
-                              <p:par>
-                                <p:cTn id="55" presetID="10" presetClass="entr" presetSubtype="0" fill="hold" nodeType="withEffect">
-                                  <p:stCondLst>
-                                    <p:cond delay="0"/>
-                                  </p:stCondLst>
-                                  <p:childTnLst>
-                                    <p:set>
-                                      <p:cBhvr>
-                                        <p:cTn id="56" dur="1" fill="hold">
-                                          <p:stCondLst>
-                                            <p:cond delay="0"/>
-                                          </p:stCondLst>
-                                        </p:cTn>
-                                        <p:tgtEl>
-                                          <p:spTgt spid="3617"/>
-                                        </p:tgtEl>
-                                        <p:attrNameLst>
-                                          <p:attrName>style.visibility</p:attrName>
-                                        </p:attrNameLst>
-                                      </p:cBhvr>
-                                      <p:to>
-                                        <p:strVal val="visible"/>
-                                      </p:to>
-                                    </p:set>
-                                    <p:animEffect transition="in" filter="fade">
-                                      <p:cBhvr>
-                                        <p:cTn id="57" dur="1000"/>
-                                        <p:tgtEl>
-                                          <p:spTgt spid="3617"/>
-                                        </p:tgtEl>
-                                      </p:cBhvr>
-                                    </p:animEffect>
-                                  </p:childTnLst>
-                                </p:cTn>
-                              </p:par>
-                              <p:par>
-                                <p:cTn id="58" presetID="10" presetClass="entr" presetSubtype="0" fill="hold" nodeType="withEffect">
-                                  <p:stCondLst>
-                                    <p:cond delay="0"/>
-                                  </p:stCondLst>
-                                  <p:childTnLst>
-                                    <p:set>
-                                      <p:cBhvr>
-                                        <p:cTn id="59" dur="1" fill="hold">
-                                          <p:stCondLst>
-                                            <p:cond delay="0"/>
-                                          </p:stCondLst>
-                                        </p:cTn>
-                                        <p:tgtEl>
-                                          <p:spTgt spid="3621"/>
-                                        </p:tgtEl>
-                                        <p:attrNameLst>
-                                          <p:attrName>style.visibility</p:attrName>
-                                        </p:attrNameLst>
-                                      </p:cBhvr>
-                                      <p:to>
-                                        <p:strVal val="visible"/>
-                                      </p:to>
-                                    </p:set>
-                                    <p:animEffect transition="in" filter="fade">
-                                      <p:cBhvr>
-                                        <p:cTn id="60" dur="1000"/>
-                                        <p:tgtEl>
-                                          <p:spTgt spid="3621"/>
-                                        </p:tgtEl>
-                                      </p:cBhvr>
-                                    </p:animEffect>
-                                  </p:childTnLst>
-                                </p:cTn>
-                              </p:par>
-                              <p:par>
-                                <p:cTn id="61" presetID="10" presetClass="entr" presetSubtype="0" fill="hold" nodeType="withEffect">
-                                  <p:stCondLst>
-                                    <p:cond delay="0"/>
-                                  </p:stCondLst>
-                                  <p:childTnLst>
-                                    <p:set>
-                                      <p:cBhvr>
-                                        <p:cTn id="62" dur="1" fill="hold">
-                                          <p:stCondLst>
-                                            <p:cond delay="0"/>
-                                          </p:stCondLst>
-                                        </p:cTn>
-                                        <p:tgtEl>
-                                          <p:spTgt spid="3622"/>
-                                        </p:tgtEl>
-                                        <p:attrNameLst>
-                                          <p:attrName>style.visibility</p:attrName>
-                                        </p:attrNameLst>
-                                      </p:cBhvr>
-                                      <p:to>
-                                        <p:strVal val="visible"/>
-                                      </p:to>
-                                    </p:set>
-                                    <p:animEffect transition="in" filter="fade">
-                                      <p:cBhvr>
-                                        <p:cTn id="63" dur="1000"/>
-                                        <p:tgtEl>
-                                          <p:spTgt spid="3622"/>
-                                        </p:tgtEl>
-                                      </p:cBhvr>
-                                    </p:animEffect>
-                                  </p:childTnLst>
-                                </p:cTn>
-                              </p:par>
-                              <p:par>
-                                <p:cTn id="64" presetID="10" presetClass="entr" presetSubtype="0" fill="hold" nodeType="withEffect">
-                                  <p:stCondLst>
-                                    <p:cond delay="0"/>
-                                  </p:stCondLst>
-                                  <p:childTnLst>
-                                    <p:set>
-                                      <p:cBhvr>
-                                        <p:cTn id="65" dur="1" fill="hold">
-                                          <p:stCondLst>
-                                            <p:cond delay="0"/>
-                                          </p:stCondLst>
-                                        </p:cTn>
-                                        <p:tgtEl>
-                                          <p:spTgt spid="3623"/>
-                                        </p:tgtEl>
-                                        <p:attrNameLst>
-                                          <p:attrName>style.visibility</p:attrName>
-                                        </p:attrNameLst>
-                                      </p:cBhvr>
-                                      <p:to>
-                                        <p:strVal val="visible"/>
-                                      </p:to>
-                                    </p:set>
-                                    <p:animEffect transition="in" filter="fade">
-                                      <p:cBhvr>
-                                        <p:cTn id="66" dur="1000"/>
-                                        <p:tgtEl>
-                                          <p:spTgt spid="3623"/>
-                                        </p:tgtEl>
-                                      </p:cBhvr>
-                                    </p:animEffect>
-                                  </p:childTnLst>
-                                </p:cTn>
-                              </p:par>
-                              <p:par>
-                                <p:cTn id="67" presetID="10" presetClass="entr" presetSubtype="0" fill="hold" nodeType="withEffect">
-                                  <p:stCondLst>
-                                    <p:cond delay="0"/>
-                                  </p:stCondLst>
-                                  <p:childTnLst>
-                                    <p:set>
-                                      <p:cBhvr>
-                                        <p:cTn id="68" dur="1" fill="hold">
-                                          <p:stCondLst>
-                                            <p:cond delay="0"/>
-                                          </p:stCondLst>
-                                        </p:cTn>
-                                        <p:tgtEl>
-                                          <p:spTgt spid="3624"/>
-                                        </p:tgtEl>
-                                        <p:attrNameLst>
-                                          <p:attrName>style.visibility</p:attrName>
-                                        </p:attrNameLst>
-                                      </p:cBhvr>
-                                      <p:to>
-                                        <p:strVal val="visible"/>
-                                      </p:to>
-                                    </p:set>
-                                    <p:animEffect transition="in" filter="fade">
-                                      <p:cBhvr>
-                                        <p:cTn id="69" dur="1000"/>
-                                        <p:tgtEl>
-                                          <p:spTgt spid="3624"/>
-                                        </p:tgtEl>
-                                      </p:cBhvr>
-                                    </p:animEffect>
-                                  </p:childTnLst>
-                                </p:cTn>
-                              </p:par>
-                              <p:par>
-                                <p:cTn id="70" presetID="10" presetClass="entr" presetSubtype="0" fill="hold" nodeType="withEffect">
-                                  <p:stCondLst>
-                                    <p:cond delay="0"/>
-                                  </p:stCondLst>
-                                  <p:childTnLst>
-                                    <p:set>
-                                      <p:cBhvr>
-                                        <p:cTn id="71" dur="1" fill="hold">
-                                          <p:stCondLst>
-                                            <p:cond delay="0"/>
-                                          </p:stCondLst>
-                                        </p:cTn>
-                                        <p:tgtEl>
-                                          <p:spTgt spid="3625"/>
-                                        </p:tgtEl>
-                                        <p:attrNameLst>
-                                          <p:attrName>style.visibility</p:attrName>
-                                        </p:attrNameLst>
-                                      </p:cBhvr>
-                                      <p:to>
-                                        <p:strVal val="visible"/>
-                                      </p:to>
-                                    </p:set>
-                                    <p:animEffect transition="in" filter="fade">
-                                      <p:cBhvr>
-                                        <p:cTn id="72" dur="1000"/>
-                                        <p:tgtEl>
-                                          <p:spTgt spid="3625"/>
-                                        </p:tgtEl>
-                                      </p:cBhvr>
-                                    </p:animEffect>
-                                  </p:childTnLst>
-                                </p:cTn>
-                              </p:par>
-                              <p:par>
-                                <p:cTn id="73" presetID="10" presetClass="entr" presetSubtype="0" fill="hold" nodeType="withEffect">
-                                  <p:stCondLst>
-                                    <p:cond delay="0"/>
-                                  </p:stCondLst>
-                                  <p:childTnLst>
-                                    <p:set>
-                                      <p:cBhvr>
-                                        <p:cTn id="74" dur="1" fill="hold">
-                                          <p:stCondLst>
-                                            <p:cond delay="0"/>
-                                          </p:stCondLst>
-                                        </p:cTn>
-                                        <p:tgtEl>
-                                          <p:spTgt spid="3626"/>
-                                        </p:tgtEl>
-                                        <p:attrNameLst>
-                                          <p:attrName>style.visibility</p:attrName>
-                                        </p:attrNameLst>
-                                      </p:cBhvr>
-                                      <p:to>
-                                        <p:strVal val="visible"/>
-                                      </p:to>
-                                    </p:set>
-                                    <p:animEffect transition="in" filter="fade">
-                                      <p:cBhvr>
-                                        <p:cTn id="75" dur="1000"/>
-                                        <p:tgtEl>
-                                          <p:spTgt spid="3626"/>
-                                        </p:tgtEl>
-                                      </p:cBhvr>
-                                    </p:animEffect>
-                                  </p:childTnLst>
-                                </p:cTn>
-                              </p:par>
-                            </p:childTnLst>
-                          </p:cTn>
-                        </p:par>
-                      </p:childTnLst>
-                    </p:cTn>
-                  </p:par>
-                  <p:par>
-                    <p:cTn id="76" fill="hold">
-                      <p:stCondLst>
-                        <p:cond delay="indefinite"/>
-                      </p:stCondLst>
-                      <p:childTnLst>
-                        <p:par>
-                          <p:cTn id="77" fill="hold">
-                            <p:stCondLst>
-                              <p:cond delay="0"/>
-                            </p:stCondLst>
-                            <p:childTnLst>
-                              <p:par>
-                                <p:cTn id="78" presetID="10" presetClass="entr" presetSubtype="0" fill="hold" nodeType="clickEffect">
-                                  <p:stCondLst>
-                                    <p:cond delay="0"/>
-                                  </p:stCondLst>
-                                  <p:childTnLst>
-                                    <p:set>
-                                      <p:cBhvr>
-                                        <p:cTn id="79" dur="1" fill="hold">
-                                          <p:stCondLst>
-                                            <p:cond delay="0"/>
-                                          </p:stCondLst>
-                                        </p:cTn>
-                                        <p:tgtEl>
-                                          <p:spTgt spid="3599"/>
-                                        </p:tgtEl>
-                                        <p:attrNameLst>
-                                          <p:attrName>style.visibility</p:attrName>
-                                        </p:attrNameLst>
-                                      </p:cBhvr>
-                                      <p:to>
-                                        <p:strVal val="visible"/>
-                                      </p:to>
-                                    </p:set>
-                                    <p:animEffect transition="in" filter="fade">
-                                      <p:cBhvr>
-                                        <p:cTn id="80" dur="1000"/>
-                                        <p:tgtEl>
-                                          <p:spTgt spid="3599"/>
-                                        </p:tgtEl>
-                                      </p:cBhvr>
-                                    </p:animEffect>
-                                  </p:childTnLst>
-                                </p:cTn>
-                              </p:par>
-                              <p:par>
-                                <p:cTn id="81" presetID="10" presetClass="entr" presetSubtype="0" fill="hold" nodeType="withEffect">
-                                  <p:stCondLst>
-                                    <p:cond delay="0"/>
-                                  </p:stCondLst>
-                                  <p:childTnLst>
-                                    <p:set>
-                                      <p:cBhvr>
-                                        <p:cTn id="82" dur="1" fill="hold">
-                                          <p:stCondLst>
-                                            <p:cond delay="0"/>
-                                          </p:stCondLst>
-                                        </p:cTn>
-                                        <p:tgtEl>
-                                          <p:spTgt spid="3600"/>
-                                        </p:tgtEl>
-                                        <p:attrNameLst>
-                                          <p:attrName>style.visibility</p:attrName>
-                                        </p:attrNameLst>
-                                      </p:cBhvr>
-                                      <p:to>
-                                        <p:strVal val="visible"/>
-                                      </p:to>
-                                    </p:set>
-                                    <p:animEffect transition="in" filter="fade">
-                                      <p:cBhvr>
-                                        <p:cTn id="83" dur="1000"/>
-                                        <p:tgtEl>
-                                          <p:spTgt spid="3600"/>
-                                        </p:tgtEl>
-                                      </p:cBhvr>
-                                    </p:animEffect>
-                                  </p:childTnLst>
-                                </p:cTn>
-                              </p:par>
-                              <p:par>
-                                <p:cTn id="84" presetID="10" presetClass="entr" presetSubtype="0" fill="hold" nodeType="withEffect">
-                                  <p:stCondLst>
-                                    <p:cond delay="0"/>
-                                  </p:stCondLst>
-                                  <p:childTnLst>
-                                    <p:set>
-                                      <p:cBhvr>
-                                        <p:cTn id="85" dur="1" fill="hold">
-                                          <p:stCondLst>
-                                            <p:cond delay="0"/>
-                                          </p:stCondLst>
-                                        </p:cTn>
-                                        <p:tgtEl>
-                                          <p:spTgt spid="3601"/>
-                                        </p:tgtEl>
-                                        <p:attrNameLst>
-                                          <p:attrName>style.visibility</p:attrName>
-                                        </p:attrNameLst>
-                                      </p:cBhvr>
-                                      <p:to>
-                                        <p:strVal val="visible"/>
-                                      </p:to>
-                                    </p:set>
-                                    <p:animEffect transition="in" filter="fade">
-                                      <p:cBhvr>
-                                        <p:cTn id="86" dur="1000"/>
-                                        <p:tgtEl>
-                                          <p:spTgt spid="3601"/>
-                                        </p:tgtEl>
-                                      </p:cBhvr>
-                                    </p:animEffect>
-                                  </p:childTnLst>
-                                </p:cTn>
-                              </p:par>
-                              <p:par>
-                                <p:cTn id="87" presetID="10" presetClass="entr" presetSubtype="0" fill="hold" nodeType="withEffect">
-                                  <p:stCondLst>
-                                    <p:cond delay="0"/>
-                                  </p:stCondLst>
-                                  <p:childTnLst>
-                                    <p:set>
-                                      <p:cBhvr>
-                                        <p:cTn id="88" dur="1" fill="hold">
-                                          <p:stCondLst>
-                                            <p:cond delay="0"/>
-                                          </p:stCondLst>
-                                        </p:cTn>
-                                        <p:tgtEl>
-                                          <p:spTgt spid="3619"/>
-                                        </p:tgtEl>
-                                        <p:attrNameLst>
-                                          <p:attrName>style.visibility</p:attrName>
-                                        </p:attrNameLst>
-                                      </p:cBhvr>
-                                      <p:to>
-                                        <p:strVal val="visible"/>
-                                      </p:to>
-                                    </p:set>
-                                    <p:animEffect transition="in" filter="fade">
-                                      <p:cBhvr>
-                                        <p:cTn id="89" dur="1000"/>
-                                        <p:tgtEl>
-                                          <p:spTgt spid="3619"/>
-                                        </p:tgtEl>
-                                      </p:cBhvr>
-                                    </p:animEffect>
-                                  </p:childTnLst>
-                                </p:cTn>
-                              </p:par>
-                              <p:par>
-                                <p:cTn id="90" presetID="10" presetClass="entr" presetSubtype="0" fill="hold" nodeType="withEffect">
-                                  <p:stCondLst>
-                                    <p:cond delay="0"/>
-                                  </p:stCondLst>
-                                  <p:childTnLst>
-                                    <p:set>
-                                      <p:cBhvr>
-                                        <p:cTn id="91" dur="1" fill="hold">
-                                          <p:stCondLst>
-                                            <p:cond delay="0"/>
-                                          </p:stCondLst>
-                                        </p:cTn>
-                                        <p:tgtEl>
-                                          <p:spTgt spid="3620"/>
-                                        </p:tgtEl>
-                                        <p:attrNameLst>
-                                          <p:attrName>style.visibility</p:attrName>
-                                        </p:attrNameLst>
-                                      </p:cBhvr>
-                                      <p:to>
-                                        <p:strVal val="visible"/>
-                                      </p:to>
-                                    </p:set>
-                                    <p:animEffect transition="in" filter="fade">
-                                      <p:cBhvr>
-                                        <p:cTn id="92" dur="1000"/>
-                                        <p:tgtEl>
-                                          <p:spTgt spid="3620"/>
-                                        </p:tgtEl>
-                                      </p:cBhvr>
-                                    </p:animEffect>
-                                  </p:childTnLst>
-                                </p:cTn>
-                              </p:par>
-                            </p:childTnLst>
-                          </p:cTn>
-                        </p:par>
-                      </p:childTnLst>
-                    </p:cTn>
-                  </p:par>
-                </p:childTnLst>
-              </p:cTn>
-              <p:prevCondLst>
-                <p:cond evt="onPrev" delay="0">
-                  <p:tgtEl>
-                    <p:sldTgt/>
-                  </p:tgtEl>
-                </p:cond>
-              </p:prevCondLst>
-              <p:nextCondLst>
-                <p:cond evt="onNext" delay="0">
-                  <p:tgtEl>
-                    <p:sldTgt/>
-                  </p:tgtEl>
-                </p:cond>
-              </p:nextCondLst>
-            </p:seq>
-          </p:childTnLst>
-        </p:cTn>
-      </p:par>
-    </p:tnLst>
-  </p:timing>
+</p:sld>
+</file>
+
+<file path=ppt/slides/slide29.xml><?xml version="1.0" encoding="utf-8"?>
+<p:sld xmlns:a="http://schemas.openxmlformats.org/drawingml/2006/main" xmlns:r="http://schemas.openxmlformats.org/officeDocument/2006/relationships" xmlns:p="http://schemas.openxmlformats.org/presentationml/2006/main">
+  <p:cSld>
+    <p:spTree>
+      <p:nvGrpSpPr>
+        <p:cNvPr id="1" name=""/>
+        <p:cNvGrpSpPr/>
+        <p:nvPr/>
+      </p:nvGrpSpPr>
+      <p:grpSpPr>
+        <a:xfrm>
+          <a:off x="0" y="0"/>
+          <a:ext cx="0" cy="0"/>
+          <a:chOff x="0" y="0"/>
+          <a:chExt cx="0" cy="0"/>
+        </a:xfrm>
+      </p:grpSpPr>
+      <p:sp>
+        <p:nvSpPr>
+          <p:cNvPr id="4" name="Title 1">
+            <a:extLst>
+              <a:ext uri="{FF2B5EF4-FFF2-40B4-BE49-F238E27FC236}">
+                <a16:creationId xmlns:a16="http://schemas.microsoft.com/office/drawing/2014/main" id="{6B638052-3E42-6054-E7C2-5095468DB402}"/>
+              </a:ext>
+            </a:extLst>
+          </p:cNvPr>
+          <p:cNvSpPr txBox="1">
+            <a:spLocks/>
+          </p:cNvSpPr>
+          <p:nvPr/>
+        </p:nvSpPr>
+        <p:spPr>
+          <a:xfrm>
+            <a:off x="838200" y="2946400"/>
+            <a:ext cx="10515600" cy="1325563"/>
+          </a:xfrm>
+          <a:prstGeom prst="rect">
+            <a:avLst/>
+          </a:prstGeom>
+        </p:spPr>
+        <p:txBody>
+          <a:bodyPr vert="horz" lIns="91440" tIns="45720" rIns="91440" bIns="45720" rtlCol="0" anchor="ctr">
+            <a:normAutofit/>
+          </a:bodyPr>
+          <a:lstStyle>
+            <a:lvl1pPr algn="l" defTabSz="914400" rtl="0" eaLnBrk="1" latinLnBrk="0" hangingPunct="1">
+              <a:lnSpc>
+                <a:spcPct val="90000"/>
+              </a:lnSpc>
+              <a:spcBef>
+                <a:spcPct val="0"/>
+              </a:spcBef>
+              <a:buNone/>
+              <a:defRPr sz="4400" kern="1200">
+                <a:solidFill>
+                  <a:schemeClr val="tx1"/>
+                </a:solidFill>
+                <a:latin typeface="+mj-lt"/>
+                <a:ea typeface="+mj-ea"/>
+                <a:cs typeface="+mj-cs"/>
+              </a:defRPr>
+            </a:lvl1pPr>
+          </a:lstStyle>
+          <a:p>
+            <a:pPr algn="ctr"/>
+            <a:r>
+              <a:rPr lang="en-GB" dirty="0"/>
+              <a:t>Let’s try MongoDB!</a:t>
+            </a:r>
+          </a:p>
+        </p:txBody>
+      </p:sp>
+    </p:spTree>
+    <p:extLst>
+      <p:ext uri="{BB962C8B-B14F-4D97-AF65-F5344CB8AC3E}">
+        <p14:creationId xmlns:p14="http://schemas.microsoft.com/office/powerpoint/2010/main" val="4222737849"/>
+      </p:ext>
+    </p:extLst>
+  </p:cSld>
+  <p:clrMapOvr>
+    <a:masterClrMapping/>
+  </p:clrMapOvr>
 </p:sld>
 </file>
 
 <file path=ppt/slides/slide3.xml><?xml version="1.0" encoding="utf-8"?>
+<p:sld xmlns:a="http://schemas.openxmlformats.org/drawingml/2006/main" xmlns:r="http://schemas.openxmlformats.org/officeDocument/2006/relationships" xmlns:p="http://schemas.openxmlformats.org/presentationml/2006/main">
+  <p:cSld>
+    <p:spTree>
+      <p:nvGrpSpPr>
+        <p:cNvPr id="1" name=""/>
+        <p:cNvGrpSpPr/>
+        <p:nvPr/>
+      </p:nvGrpSpPr>
+      <p:grpSpPr>
+        <a:xfrm>
+          <a:off x="0" y="0"/>
+          <a:ext cx="0" cy="0"/>
+          <a:chOff x="0" y="0"/>
+          <a:chExt cx="0" cy="0"/>
+        </a:xfrm>
+      </p:grpSpPr>
+      <p:sp>
+        <p:nvSpPr>
+          <p:cNvPr id="2" name="Title 1">
+            <a:extLst>
+              <a:ext uri="{FF2B5EF4-FFF2-40B4-BE49-F238E27FC236}">
+                <a16:creationId xmlns:a16="http://schemas.microsoft.com/office/drawing/2014/main" id="{2DF2FDBA-355F-CFE6-F0EA-FCFA5341ACAE}"/>
+              </a:ext>
+            </a:extLst>
+          </p:cNvPr>
+          <p:cNvSpPr>
+            <a:spLocks noGrp="1"/>
+          </p:cNvSpPr>
+          <p:nvPr>
+            <p:ph type="title"/>
+          </p:nvPr>
+        </p:nvSpPr>
+        <p:spPr/>
+        <p:txBody>
+          <a:bodyPr/>
+          <a:lstStyle/>
+          <a:p>
+            <a:r>
+              <a:rPr lang="en-GB" dirty="0"/>
+              <a:t>Relational vs Non-Relational Model</a:t>
+            </a:r>
+          </a:p>
+        </p:txBody>
+      </p:sp>
+      <p:sp>
+        <p:nvSpPr>
+          <p:cNvPr id="3" name="Content Placeholder 2">
+            <a:extLst>
+              <a:ext uri="{FF2B5EF4-FFF2-40B4-BE49-F238E27FC236}">
+                <a16:creationId xmlns:a16="http://schemas.microsoft.com/office/drawing/2014/main" id="{41621D54-7A72-870D-5571-B90246632F31}"/>
+              </a:ext>
+            </a:extLst>
+          </p:cNvPr>
+          <p:cNvSpPr>
+            <a:spLocks noGrp="1"/>
+          </p:cNvSpPr>
+          <p:nvPr>
+            <p:ph idx="1"/>
+          </p:nvPr>
+        </p:nvSpPr>
+        <p:spPr/>
+        <p:txBody>
+          <a:bodyPr/>
+          <a:lstStyle/>
+          <a:p>
+            <a:endParaRPr lang="en-GB" dirty="0"/>
+          </a:p>
+        </p:txBody>
+      </p:sp>
+    </p:spTree>
+    <p:extLst>
+      <p:ext uri="{BB962C8B-B14F-4D97-AF65-F5344CB8AC3E}">
+        <p14:creationId xmlns:p14="http://schemas.microsoft.com/office/powerpoint/2010/main" val="961389852"/>
+      </p:ext>
+    </p:extLst>
+  </p:cSld>
+  <p:clrMapOvr>
+    <a:masterClrMapping/>
+  </p:clrMapOvr>
+</p:sld>
+</file>
+
+<file path=ppt/slides/slide4.xml><?xml version="1.0" encoding="utf-8"?>
 <p:sld xmlns:a="http://schemas.openxmlformats.org/drawingml/2006/main" xmlns:r="http://schemas.openxmlformats.org/officeDocument/2006/relationships" xmlns:p="http://schemas.openxmlformats.org/presentationml/2006/main">
   <p:cSld>
     <p:spTree>
@@ -11793,7 +11138,7 @@
 </p:sld>
 </file>
 
-<file path=ppt/slides/slide4.xml><?xml version="1.0" encoding="utf-8"?>
+<file path=ppt/slides/slide5.xml><?xml version="1.0" encoding="utf-8"?>
 <p:sld xmlns:a="http://schemas.openxmlformats.org/drawingml/2006/main" xmlns:r="http://schemas.openxmlformats.org/officeDocument/2006/relationships" xmlns:p="http://schemas.openxmlformats.org/presentationml/2006/main">
   <p:cSld>
     <p:spTree>
@@ -12067,7 +11412,7 @@
                             </p:stCondLst>
                             <p:childTnLst>
                               <p:par>
-                                <p:cTn id="5" presetID="10" presetClass="entr" presetSubtype="0" fill="hold" grpId="0" nodeType="clickEffect">
+                                <p:cTn id="5" presetID="10" presetClass="entr" presetSubtype="0" fill="hold" nodeType="clickEffect">
                                   <p:stCondLst>
                                     <p:cond delay="0"/>
                                   </p:stCondLst>
@@ -12075,6 +11420,59 @@
                                     <p:set>
                                       <p:cBhvr>
                                         <p:cTn id="6" dur="1" fill="hold">
+                                          <p:stCondLst>
+                                            <p:cond delay="0"/>
+                                          </p:stCondLst>
+                                        </p:cTn>
+                                        <p:tgtEl>
+                                          <p:spTgt spid="3074"/>
+                                        </p:tgtEl>
+                                        <p:attrNameLst>
+                                          <p:attrName>style.visibility</p:attrName>
+                                        </p:attrNameLst>
+                                      </p:cBhvr>
+                                      <p:to>
+                                        <p:strVal val="visible"/>
+                                      </p:to>
+                                    </p:set>
+                                    <p:animEffect transition="in" filter="fade">
+                                      <p:cBhvr>
+                                        <p:cTn id="7" dur="500"/>
+                                        <p:tgtEl>
+                                          <p:spTgt spid="3074"/>
+                                        </p:tgtEl>
+                                      </p:cBhvr>
+                                    </p:animEffect>
+                                  </p:childTnLst>
+                                </p:cTn>
+                              </p:par>
+                            </p:childTnLst>
+                          </p:cTn>
+                        </p:par>
+                      </p:childTnLst>
+                    </p:cTn>
+                  </p:par>
+                  <p:par>
+                    <p:cTn id="8" fill="hold">
+                      <p:stCondLst>
+                        <p:cond delay="indefinite"/>
+                      </p:stCondLst>
+                      <p:childTnLst>
+                        <p:par>
+                          <p:cTn id="9" fill="hold">
+                            <p:stCondLst>
+                              <p:cond delay="0"/>
+                            </p:stCondLst>
+                            <p:childTnLst>
+                              <p:par>
+                                <p:cTn id="10" presetID="10" presetClass="entr" presetSubtype="0" fill="hold" grpId="0" nodeType="clickEffect">
+                                  <p:stCondLst>
+                                    <p:cond delay="0"/>
+                                  </p:stCondLst>
+                                  <p:childTnLst>
+                                    <p:set>
+                                      <p:cBhvr>
+                                        <p:cTn id="11" dur="1" fill="hold">
                                           <p:stCondLst>
                                             <p:cond delay="0"/>
                                           </p:stCondLst>
@@ -12092,44 +11490,9 @@
                                     </p:set>
                                     <p:animEffect transition="in" filter="fade">
                                       <p:cBhvr>
-                                        <p:cTn id="7" dur="500"/>
+                                        <p:cTn id="12" dur="500"/>
                                         <p:tgtEl>
                                           <p:spTgt spid="22"/>
-                                        </p:tgtEl>
-                                      </p:cBhvr>
-                                    </p:animEffect>
-                                  </p:childTnLst>
-                                </p:cTn>
-                              </p:par>
-                              <p:par>
-                                <p:cTn id="8" presetID="10" presetClass="entr" presetSubtype="0" fill="hold" nodeType="withEffect">
-                                  <p:stCondLst>
-                                    <p:cond delay="0"/>
-                                  </p:stCondLst>
-                                  <p:childTnLst>
-                                    <p:set>
-                                      <p:cBhvr>
-                                        <p:cTn id="9" dur="1" fill="hold">
-                                          <p:stCondLst>
-                                            <p:cond delay="0"/>
-                                          </p:stCondLst>
-                                        </p:cTn>
-                                        <p:tgtEl>
-                                          <p:spTgt spid="3074"/>
-                                        </p:tgtEl>
-                                        <p:attrNameLst>
-                                          <p:attrName>style.visibility</p:attrName>
-                                        </p:attrNameLst>
-                                      </p:cBhvr>
-                                      <p:to>
-                                        <p:strVal val="visible"/>
-                                      </p:to>
-                                    </p:set>
-                                    <p:animEffect transition="in" filter="fade">
-                                      <p:cBhvr>
-                                        <p:cTn id="10" dur="500"/>
-                                        <p:tgtEl>
-                                          <p:spTgt spid="3074"/>
                                         </p:tgtEl>
                                       </p:cBhvr>
                                     </p:animEffect>
@@ -12170,7 +11533,7 @@
 </p:sld>
 </file>
 
-<file path=ppt/slides/slide5.xml><?xml version="1.0" encoding="utf-8"?>
+<file path=ppt/slides/slide6.xml><?xml version="1.0" encoding="utf-8"?>
 <p:sld xmlns:a="http://schemas.openxmlformats.org/drawingml/2006/main" xmlns:r="http://schemas.openxmlformats.org/officeDocument/2006/relationships" xmlns:p="http://schemas.openxmlformats.org/presentationml/2006/main">
   <p:cSld>
     <p:spTree>
@@ -13187,70 +12550,6 @@
 </p:sld>
 </file>
 
-<file path=ppt/slides/slide6.xml><?xml version="1.0" encoding="utf-8"?>
-<p:sld xmlns:a="http://schemas.openxmlformats.org/drawingml/2006/main" xmlns:r="http://schemas.openxmlformats.org/officeDocument/2006/relationships" xmlns:p="http://schemas.openxmlformats.org/presentationml/2006/main">
-  <p:cSld>
-    <p:spTree>
-      <p:nvGrpSpPr>
-        <p:cNvPr id="1" name=""/>
-        <p:cNvGrpSpPr/>
-        <p:nvPr/>
-      </p:nvGrpSpPr>
-      <p:grpSpPr>
-        <a:xfrm>
-          <a:off x="0" y="0"/>
-          <a:ext cx="0" cy="0"/>
-          <a:chOff x="0" y="0"/>
-          <a:chExt cx="0" cy="0"/>
-        </a:xfrm>
-      </p:grpSpPr>
-      <p:sp>
-        <p:nvSpPr>
-          <p:cNvPr id="4" name="Title 1">
-            <a:extLst>
-              <a:ext uri="{FF2B5EF4-FFF2-40B4-BE49-F238E27FC236}">
-                <a16:creationId xmlns:a16="http://schemas.microsoft.com/office/drawing/2014/main" id="{C309BA76-E4FB-050C-659B-DC925767F144}"/>
-              </a:ext>
-            </a:extLst>
-          </p:cNvPr>
-          <p:cNvSpPr>
-            <a:spLocks noGrp="1"/>
-          </p:cNvSpPr>
-          <p:nvPr>
-            <p:ph type="title"/>
-          </p:nvPr>
-        </p:nvSpPr>
-        <p:spPr>
-          <a:xfrm>
-            <a:off x="838200" y="2766218"/>
-            <a:ext cx="10515600" cy="1325563"/>
-          </a:xfrm>
-        </p:spPr>
-        <p:txBody>
-          <a:bodyPr/>
-          <a:lstStyle/>
-          <a:p>
-            <a:pPr algn="ctr"/>
-            <a:r>
-              <a:rPr lang="en-GB" dirty="0"/>
-              <a:t>Non-Relational Model</a:t>
-            </a:r>
-          </a:p>
-        </p:txBody>
-      </p:sp>
-    </p:spTree>
-    <p:extLst>
-      <p:ext uri="{BB962C8B-B14F-4D97-AF65-F5344CB8AC3E}">
-        <p14:creationId xmlns:p14="http://schemas.microsoft.com/office/powerpoint/2010/main" val="515459701"/>
-      </p:ext>
-    </p:extLst>
-  </p:cSld>
-  <p:clrMapOvr>
-    <a:masterClrMapping/>
-  </p:clrMapOvr>
-</p:sld>
-</file>
-
 <file path=ppt/slides/slide7.xml><?xml version="1.0" encoding="utf-8"?>
 <p:sld xmlns:a="http://schemas.openxmlformats.org/drawingml/2006/main" xmlns:r="http://schemas.openxmlformats.org/officeDocument/2006/relationships" xmlns:p="http://schemas.openxmlformats.org/presentationml/2006/main">
   <p:cSld>
@@ -13270,10 +12569,10 @@
       </p:grpSpPr>
       <p:sp>
         <p:nvSpPr>
-          <p:cNvPr id="2" name="Title 1">
-            <a:extLst>
-              <a:ext uri="{FF2B5EF4-FFF2-40B4-BE49-F238E27FC236}">
-                <a16:creationId xmlns:a16="http://schemas.microsoft.com/office/drawing/2014/main" id="{B7219CD3-C084-94EB-42D1-0EC948B46392}"/>
+          <p:cNvPr id="4" name="Title 1">
+            <a:extLst>
+              <a:ext uri="{FF2B5EF4-FFF2-40B4-BE49-F238E27FC236}">
+                <a16:creationId xmlns:a16="http://schemas.microsoft.com/office/drawing/2014/main" id="{C309BA76-E4FB-050C-659B-DC925767F144}"/>
               </a:ext>
             </a:extLst>
           </p:cNvPr>
@@ -13284,150 +12583,28 @@
             <p:ph type="title"/>
           </p:nvPr>
         </p:nvSpPr>
-        <p:spPr/>
+        <p:spPr>
+          <a:xfrm>
+            <a:off x="838200" y="2766218"/>
+            <a:ext cx="10515600" cy="1325563"/>
+          </a:xfrm>
+        </p:spPr>
         <p:txBody>
           <a:bodyPr/>
           <a:lstStyle/>
           <a:p>
+            <a:pPr algn="ctr"/>
             <a:r>
               <a:rPr lang="en-GB" dirty="0"/>
-              <a:t>Non-Relational Model: Data structure</a:t>
-            </a:r>
-          </a:p>
-        </p:txBody>
-      </p:sp>
-      <p:pic>
-        <p:nvPicPr>
-          <p:cNvPr id="2050" name="Picture 2">
-            <a:extLst>
-              <a:ext uri="{FF2B5EF4-FFF2-40B4-BE49-F238E27FC236}">
-                <a16:creationId xmlns:a16="http://schemas.microsoft.com/office/drawing/2014/main" id="{5DE22875-47EE-B24E-FA83-5C19FAE566FD}"/>
-              </a:ext>
-            </a:extLst>
-          </p:cNvPr>
-          <p:cNvPicPr>
-            <a:picLocks noChangeAspect="1" noChangeArrowheads="1"/>
-          </p:cNvPicPr>
-          <p:nvPr/>
-        </p:nvPicPr>
-        <p:blipFill>
-          <a:blip r:embed="rId2">
-            <a:extLst>
-              <a:ext uri="{28A0092B-C50C-407E-A947-70E740481C1C}">
-                <a14:useLocalDpi xmlns:a14="http://schemas.microsoft.com/office/drawing/2010/main" val="0"/>
-              </a:ext>
-            </a:extLst>
-          </a:blip>
-          <a:srcRect/>
-          <a:stretch>
-            <a:fillRect/>
-          </a:stretch>
-        </p:blipFill>
-        <p:spPr bwMode="auto">
-          <a:xfrm>
-            <a:off x="838200" y="2016125"/>
-            <a:ext cx="3362325" cy="3362325"/>
-          </a:xfrm>
-          <a:prstGeom prst="rect">
-            <a:avLst/>
-          </a:prstGeom>
-          <a:noFill/>
-          <a:extLst>
-            <a:ext uri="{909E8E84-426E-40DD-AFC4-6F175D3DCCD1}">
-              <a14:hiddenFill xmlns:a14="http://schemas.microsoft.com/office/drawing/2010/main">
-                <a:solidFill>
-                  <a:srgbClr val="FFFFFF"/>
-                </a:solidFill>
-              </a14:hiddenFill>
-            </a:ext>
-          </a:extLst>
-        </p:spPr>
-      </p:pic>
-      <p:sp>
-        <p:nvSpPr>
-          <p:cNvPr id="6" name="TextBox 5">
-            <a:extLst>
-              <a:ext uri="{FF2B5EF4-FFF2-40B4-BE49-F238E27FC236}">
-                <a16:creationId xmlns:a16="http://schemas.microsoft.com/office/drawing/2014/main" id="{DF663E07-623C-8C20-04F2-F7575BEB4081}"/>
-              </a:ext>
-            </a:extLst>
-          </p:cNvPr>
-          <p:cNvSpPr txBox="1"/>
-          <p:nvPr/>
-        </p:nvSpPr>
-        <p:spPr>
-          <a:xfrm>
-            <a:off x="5114925" y="2016125"/>
-            <a:ext cx="5057775" cy="1200329"/>
-          </a:xfrm>
-          <a:prstGeom prst="rect">
-            <a:avLst/>
-          </a:prstGeom>
-          <a:noFill/>
-        </p:spPr>
-        <p:txBody>
-          <a:bodyPr wrap="square" rtlCol="0">
-            <a:spAutoFit/>
-          </a:bodyPr>
-          <a:lstStyle/>
-          <a:p>
-            <a:pPr marL="285750" indent="-285750">
-              <a:buFont typeface="Arial" panose="020B0604020202020204" pitchFamily="34" charset="0"/>
-              <a:buChar char="•"/>
-            </a:pPr>
-            <a:r>
-              <a:rPr lang="en-GB" sz="1800" dirty="0">
-                <a:latin typeface="Lexend Deca Light"/>
-                <a:ea typeface="Lexend Deca Light"/>
-                <a:cs typeface="Lexend Deca Light"/>
-                <a:sym typeface="Lexend Deca Light"/>
-              </a:rPr>
-              <a:t>Polymorphic data structures</a:t>
-            </a:r>
-          </a:p>
-          <a:p>
-            <a:pPr marL="285750" indent="-285750">
-              <a:buFont typeface="Arial" panose="020B0604020202020204" pitchFamily="34" charset="0"/>
-              <a:buChar char="•"/>
-            </a:pPr>
-            <a:r>
-              <a:rPr lang="en-GB" sz="1800" dirty="0">
-                <a:latin typeface="Lexend Deca Light"/>
-                <a:ea typeface="Lexend Deca Light"/>
-                <a:cs typeface="Lexend Deca Light"/>
-                <a:sym typeface="Lexend Deca Light"/>
-              </a:rPr>
-              <a:t>Flexible schemas</a:t>
-            </a:r>
-          </a:p>
-          <a:p>
-            <a:pPr marL="285750" indent="-285750">
-              <a:buFont typeface="Arial" panose="020B0604020202020204" pitchFamily="34" charset="0"/>
-              <a:buChar char="•"/>
-            </a:pPr>
-            <a:r>
-              <a:rPr lang="en-GB" sz="1800" dirty="0">
-                <a:latin typeface="Lexend Deca Light"/>
-                <a:ea typeface="Lexend Deca Light"/>
-                <a:cs typeface="Lexend Deca Light"/>
-                <a:sym typeface="Lexend Deca Light"/>
-              </a:rPr>
-              <a:t>Easy to scale large workloads</a:t>
-            </a:r>
-          </a:p>
-          <a:p>
-            <a:pPr marL="285750" indent="-285750">
-              <a:buFont typeface="Arial" panose="020B0604020202020204" pitchFamily="34" charset="0"/>
-              <a:buChar char="•"/>
-            </a:pPr>
-            <a:endParaRPr lang="en-GB" dirty="0"/>
+              <a:t>Non-Relational Model</a:t>
+            </a:r>
           </a:p>
         </p:txBody>
       </p:sp>
     </p:spTree>
     <p:extLst>
       <p:ext uri="{BB962C8B-B14F-4D97-AF65-F5344CB8AC3E}">
-        <p14:creationId xmlns:p14="http://schemas.microsoft.com/office/powerpoint/2010/main" val="890216197"/>
+        <p14:creationId xmlns:p14="http://schemas.microsoft.com/office/powerpoint/2010/main" val="515459701"/>
       </p:ext>
     </p:extLst>
   </p:cSld>
@@ -13456,171 +12633,38 @@
       </p:grpSpPr>
       <p:sp>
         <p:nvSpPr>
-          <p:cNvPr id="14" name="Google Shape;2451;p169">
-            <a:extLst>
-              <a:ext uri="{FF2B5EF4-FFF2-40B4-BE49-F238E27FC236}">
-                <a16:creationId xmlns:a16="http://schemas.microsoft.com/office/drawing/2014/main" id="{058FF298-5B87-3216-F623-6C035C5973C8}"/>
-              </a:ext>
-            </a:extLst>
-          </p:cNvPr>
-          <p:cNvSpPr txBox="1">
-            <a:spLocks/>
+          <p:cNvPr id="2" name="Title 1">
+            <a:extLst>
+              <a:ext uri="{FF2B5EF4-FFF2-40B4-BE49-F238E27FC236}">
+                <a16:creationId xmlns:a16="http://schemas.microsoft.com/office/drawing/2014/main" id="{B7219CD3-C084-94EB-42D1-0EC948B46392}"/>
+              </a:ext>
+            </a:extLst>
+          </p:cNvPr>
+          <p:cNvSpPr>
+            <a:spLocks noGrp="1"/>
           </p:cNvSpPr>
-          <p:nvPr/>
-        </p:nvSpPr>
-        <p:spPr>
-          <a:xfrm>
-            <a:off x="830300" y="821000"/>
-            <a:ext cx="9943600" cy="615600"/>
-          </a:xfrm>
-          <a:prstGeom prst="rect">
-            <a:avLst/>
-          </a:prstGeom>
-        </p:spPr>
-        <p:txBody>
-          <a:bodyPr spcFirstLastPara="1" vert="horz" wrap="square" lIns="0" tIns="0" rIns="0" bIns="0" rtlCol="0" anchor="t" anchorCtr="0">
-            <a:noAutofit/>
-          </a:bodyPr>
-          <a:lstStyle>
-            <a:lvl1pPr algn="l" defTabSz="914400" rtl="0" eaLnBrk="1" latinLnBrk="0" hangingPunct="1">
-              <a:lnSpc>
-                <a:spcPct val="90000"/>
-              </a:lnSpc>
-              <a:spcBef>
-                <a:spcPct val="0"/>
-              </a:spcBef>
-              <a:buNone/>
-              <a:defRPr sz="4400" kern="1200">
-                <a:solidFill>
-                  <a:schemeClr val="tx1"/>
-                </a:solidFill>
-                <a:latin typeface="+mj-lt"/>
-                <a:ea typeface="+mj-ea"/>
-                <a:cs typeface="+mj-cs"/>
-              </a:defRPr>
-            </a:lvl1pPr>
-          </a:lstStyle>
-          <a:p>
-            <a:r>
-              <a:rPr lang="en-GB" sz="4800" dirty="0"/>
-              <a:t>Non-Relational Model: Scaling</a:t>
-            </a:r>
-            <a:endParaRPr lang="en-GB" dirty="0"/>
-          </a:p>
-        </p:txBody>
-      </p:sp>
-      <p:sp>
-        <p:nvSpPr>
-          <p:cNvPr id="15" name="Google Shape;2452;p169">
-            <a:extLst>
-              <a:ext uri="{FF2B5EF4-FFF2-40B4-BE49-F238E27FC236}">
-                <a16:creationId xmlns:a16="http://schemas.microsoft.com/office/drawing/2014/main" id="{87E7EEF5-9F92-CFB7-E820-9408A0587643}"/>
-              </a:ext>
-            </a:extLst>
-          </p:cNvPr>
-          <p:cNvSpPr txBox="1">
-            <a:spLocks/>
-          </p:cNvSpPr>
-          <p:nvPr/>
-        </p:nvSpPr>
-        <p:spPr>
-          <a:xfrm>
-            <a:off x="1132400" y="1956133"/>
-            <a:ext cx="4374800" cy="502000"/>
-          </a:xfrm>
-          <a:prstGeom prst="rect">
-            <a:avLst/>
-          </a:prstGeom>
-        </p:spPr>
-        <p:txBody>
-          <a:bodyPr spcFirstLastPara="1" vert="horz" wrap="square" lIns="0" tIns="0" rIns="0" bIns="0" rtlCol="0" anchor="t" anchorCtr="0">
-            <a:noAutofit/>
-          </a:bodyPr>
-          <a:lstStyle>
-            <a:lvl1pPr algn="l" defTabSz="914400" rtl="0" eaLnBrk="1" latinLnBrk="0" hangingPunct="1">
-              <a:lnSpc>
-                <a:spcPct val="90000"/>
-              </a:lnSpc>
-              <a:spcBef>
-                <a:spcPct val="0"/>
-              </a:spcBef>
-              <a:buNone/>
-              <a:defRPr sz="4400" kern="1200">
-                <a:solidFill>
-                  <a:schemeClr val="tx1"/>
-                </a:solidFill>
-                <a:latin typeface="+mj-lt"/>
-                <a:ea typeface="+mj-ea"/>
-                <a:cs typeface="+mj-cs"/>
-              </a:defRPr>
-            </a:lvl1pPr>
-          </a:lstStyle>
-          <a:p>
-            <a:pPr>
-              <a:lnSpc>
-                <a:spcPct val="100000"/>
-              </a:lnSpc>
-            </a:pPr>
-            <a:endParaRPr lang="en-GB" dirty="0">
-              <a:solidFill>
-                <a:srgbClr val="000000"/>
-              </a:solidFill>
-              <a:latin typeface="+mn-lt"/>
-            </a:endParaRPr>
-          </a:p>
-        </p:txBody>
-      </p:sp>
-      <p:sp>
-        <p:nvSpPr>
-          <p:cNvPr id="22" name="TextBox 21">
-            <a:extLst>
-              <a:ext uri="{FF2B5EF4-FFF2-40B4-BE49-F238E27FC236}">
-                <a16:creationId xmlns:a16="http://schemas.microsoft.com/office/drawing/2014/main" id="{D83D3F4C-B07D-F97C-F3F9-5ED9D17827D1}"/>
-              </a:ext>
-            </a:extLst>
-          </p:cNvPr>
-          <p:cNvSpPr txBox="1"/>
-          <p:nvPr/>
-        </p:nvSpPr>
-        <p:spPr>
-          <a:xfrm>
-            <a:off x="830300" y="4677342"/>
-            <a:ext cx="8894725" cy="954107"/>
-          </a:xfrm>
-          <a:prstGeom prst="rect">
-            <a:avLst/>
-          </a:prstGeom>
-          <a:noFill/>
-        </p:spPr>
-        <p:txBody>
-          <a:bodyPr wrap="square" rtlCol="0">
-            <a:spAutoFit/>
-          </a:bodyPr>
+          <p:nvPr>
+            <p:ph type="title"/>
+          </p:nvPr>
+        </p:nvSpPr>
+        <p:spPr/>
+        <p:txBody>
+          <a:bodyPr/>
           <a:lstStyle/>
           <a:p>
             <a:r>
-              <a:rPr lang="en-GB" sz="2800" dirty="0"/>
-              <a:t>Horizontal Scaling</a:t>
-            </a:r>
-          </a:p>
-          <a:p>
-            <a:pPr marL="285750" indent="-285750">
-              <a:buFont typeface="Arial" panose="020B0604020202020204" pitchFamily="34" charset="0"/>
-              <a:buChar char="•"/>
-            </a:pPr>
-            <a:r>
-              <a:rPr lang="en-GB" sz="2800" dirty="0"/>
-              <a:t>Add more machines/instances to distribute the load</a:t>
+              <a:rPr lang="en-GB" dirty="0"/>
+              <a:t>Non-Relational Model: Data structure</a:t>
             </a:r>
           </a:p>
         </p:txBody>
       </p:sp>
       <p:pic>
         <p:nvPicPr>
-          <p:cNvPr id="5122" name="Picture 2">
-            <a:extLst>
-              <a:ext uri="{FF2B5EF4-FFF2-40B4-BE49-F238E27FC236}">
-                <a16:creationId xmlns:a16="http://schemas.microsoft.com/office/drawing/2014/main" id="{0A085192-9629-940A-B952-2E482ED5C069}"/>
+          <p:cNvPr id="2050" name="Picture 2">
+            <a:extLst>
+              <a:ext uri="{FF2B5EF4-FFF2-40B4-BE49-F238E27FC236}">
+                <a16:creationId xmlns:a16="http://schemas.microsoft.com/office/drawing/2014/main" id="{5DE22875-47EE-B24E-FA83-5C19FAE566FD}"/>
               </a:ext>
             </a:extLst>
           </p:cNvPr>
@@ -13629,7 +12673,7 @@
           </p:cNvPicPr>
           <p:nvPr/>
         </p:nvPicPr>
-        <p:blipFill rotWithShape="1">
+        <p:blipFill>
           <a:blip r:embed="rId2">
             <a:extLst>
               <a:ext uri="{28A0092B-C50C-407E-A947-70E740481C1C}">
@@ -13637,13 +12681,15 @@
               </a:ext>
             </a:extLst>
           </a:blip>
-          <a:srcRect l="39062"/>
-          <a:stretch/>
+          <a:srcRect/>
+          <a:stretch>
+            <a:fillRect/>
+          </a:stretch>
         </p:blipFill>
         <p:spPr bwMode="auto">
           <a:xfrm>
-            <a:off x="186611" y="418356"/>
-            <a:ext cx="7338139" cy="3855659"/>
+            <a:off x="838200" y="2016125"/>
+            <a:ext cx="3362325" cy="3362325"/>
           </a:xfrm>
           <a:prstGeom prst="rect">
             <a:avLst/>
@@ -13660,10 +12706,91 @@
           </a:extLst>
         </p:spPr>
       </p:pic>
+      <p:sp>
+        <p:nvSpPr>
+          <p:cNvPr id="6" name="TextBox 5">
+            <a:extLst>
+              <a:ext uri="{FF2B5EF4-FFF2-40B4-BE49-F238E27FC236}">
+                <a16:creationId xmlns:a16="http://schemas.microsoft.com/office/drawing/2014/main" id="{DF663E07-623C-8C20-04F2-F7575BEB4081}"/>
+              </a:ext>
+            </a:extLst>
+          </p:cNvPr>
+          <p:cNvSpPr txBox="1"/>
+          <p:nvPr/>
+        </p:nvSpPr>
+        <p:spPr>
+          <a:xfrm>
+            <a:off x="5114925" y="2016125"/>
+            <a:ext cx="5057775" cy="1200329"/>
+          </a:xfrm>
+          <a:prstGeom prst="rect">
+            <a:avLst/>
+          </a:prstGeom>
+          <a:noFill/>
+        </p:spPr>
+        <p:txBody>
+          <a:bodyPr wrap="square" rtlCol="0">
+            <a:spAutoFit/>
+          </a:bodyPr>
+          <a:lstStyle/>
+          <a:p>
+            <a:pPr marL="285750" indent="-285750">
+              <a:buFont typeface="Arial" panose="020B0604020202020204" pitchFamily="34" charset="0"/>
+              <a:buChar char="•"/>
+            </a:pPr>
+            <a:r>
+              <a:rPr lang="en-GB" sz="1800" dirty="0">
+                <a:latin typeface="Lexend Deca Light"/>
+                <a:ea typeface="Lexend Deca Light"/>
+                <a:cs typeface="Lexend Deca Light"/>
+                <a:sym typeface="Lexend Deca Light"/>
+              </a:rPr>
+              <a:t>Polymorphic data structures</a:t>
+            </a:r>
+          </a:p>
+          <a:p>
+            <a:pPr marL="285750" indent="-285750">
+              <a:buFont typeface="Arial" panose="020B0604020202020204" pitchFamily="34" charset="0"/>
+              <a:buChar char="•"/>
+            </a:pPr>
+            <a:r>
+              <a:rPr lang="en-GB" sz="1800" dirty="0">
+                <a:latin typeface="Lexend Deca Light"/>
+                <a:ea typeface="Lexend Deca Light"/>
+                <a:cs typeface="Lexend Deca Light"/>
+                <a:sym typeface="Lexend Deca Light"/>
+              </a:rPr>
+              <a:t>Flexible schemas</a:t>
+            </a:r>
+          </a:p>
+          <a:p>
+            <a:pPr marL="285750" indent="-285750">
+              <a:buFont typeface="Arial" panose="020B0604020202020204" pitchFamily="34" charset="0"/>
+              <a:buChar char="•"/>
+            </a:pPr>
+            <a:r>
+              <a:rPr lang="en-GB" sz="1800" dirty="0">
+                <a:latin typeface="Lexend Deca Light"/>
+                <a:ea typeface="Lexend Deca Light"/>
+                <a:cs typeface="Lexend Deca Light"/>
+                <a:sym typeface="Lexend Deca Light"/>
+              </a:rPr>
+              <a:t>Easy to scale large workloads</a:t>
+            </a:r>
+          </a:p>
+          <a:p>
+            <a:pPr marL="285750" indent="-285750">
+              <a:buFont typeface="Arial" panose="020B0604020202020204" pitchFamily="34" charset="0"/>
+              <a:buChar char="•"/>
+            </a:pPr>
+            <a:endParaRPr lang="en-GB" dirty="0"/>
+          </a:p>
+        </p:txBody>
+      </p:sp>
     </p:spTree>
     <p:extLst>
       <p:ext uri="{BB962C8B-B14F-4D97-AF65-F5344CB8AC3E}">
-        <p14:creationId xmlns:p14="http://schemas.microsoft.com/office/powerpoint/2010/main" val="3769292591"/>
+        <p14:creationId xmlns:p14="http://schemas.microsoft.com/office/powerpoint/2010/main" val="890216197"/>
       </p:ext>
     </p:extLst>
   </p:cSld>
@@ -13739,9 +12866,9 @@
           <a:p>
             <a:r>
               <a:rPr lang="en-GB" sz="4800" dirty="0"/>
-              <a:t>Non-Relational Model: Sharding</a:t>
-            </a:r>
-            <a:endParaRPr lang="en-GB" sz="2000" dirty="0"/>
+              <a:t>Non-Relational Model: Scaling</a:t>
+            </a:r>
+            <a:endParaRPr lang="en-GB" dirty="0"/>
           </a:p>
         </p:txBody>
       </p:sp>
@@ -13820,8 +12947,8 @@
         </p:nvSpPr>
         <p:spPr>
           <a:xfrm>
-            <a:off x="830300" y="1781858"/>
-            <a:ext cx="8370850" cy="954107"/>
+            <a:off x="830300" y="4677342"/>
+            <a:ext cx="8894725" cy="954107"/>
           </a:xfrm>
           <a:prstGeom prst="rect">
             <a:avLst/>
@@ -13834,31 +12961,72 @@
           </a:bodyPr>
           <a:lstStyle/>
           <a:p>
-            <a:pPr marL="457200" indent="-457200">
+            <a:r>
+              <a:rPr lang="en-GB" sz="2800" dirty="0"/>
+              <a:t>Horizontal Scaling</a:t>
+            </a:r>
+          </a:p>
+          <a:p>
+            <a:pPr marL="285750" indent="-285750">
               <a:buFont typeface="Arial" panose="020B0604020202020204" pitchFamily="34" charset="0"/>
               <a:buChar char="•"/>
             </a:pPr>
             <a:r>
               <a:rPr lang="en-GB" sz="2800" dirty="0"/>
-              <a:t>Concept is the same as in Relational model</a:t>
-            </a:r>
-          </a:p>
-          <a:p>
-            <a:pPr marL="457200" indent="-457200">
-              <a:buFont typeface="Arial" panose="020B0604020202020204" pitchFamily="34" charset="0"/>
-              <a:buChar char="•"/>
-            </a:pPr>
-            <a:r>
-              <a:rPr lang="en-GB" sz="2800" dirty="0"/>
-              <a:t>Sharding is part of the architecture of NoSQL</a:t>
-            </a:r>
-          </a:p>
-        </p:txBody>
-      </p:sp>
+              <a:t>Add more machines/instances to distribute the load</a:t>
+            </a:r>
+          </a:p>
+        </p:txBody>
+      </p:sp>
+      <p:pic>
+        <p:nvPicPr>
+          <p:cNvPr id="5122" name="Picture 2">
+            <a:extLst>
+              <a:ext uri="{FF2B5EF4-FFF2-40B4-BE49-F238E27FC236}">
+                <a16:creationId xmlns:a16="http://schemas.microsoft.com/office/drawing/2014/main" id="{0A085192-9629-940A-B952-2E482ED5C069}"/>
+              </a:ext>
+            </a:extLst>
+          </p:cNvPr>
+          <p:cNvPicPr>
+            <a:picLocks noChangeAspect="1" noChangeArrowheads="1"/>
+          </p:cNvPicPr>
+          <p:nvPr/>
+        </p:nvPicPr>
+        <p:blipFill rotWithShape="1">
+          <a:blip r:embed="rId2">
+            <a:extLst>
+              <a:ext uri="{28A0092B-C50C-407E-A947-70E740481C1C}">
+                <a14:useLocalDpi xmlns:a14="http://schemas.microsoft.com/office/drawing/2010/main" val="0"/>
+              </a:ext>
+            </a:extLst>
+          </a:blip>
+          <a:srcRect l="39062"/>
+          <a:stretch/>
+        </p:blipFill>
+        <p:spPr bwMode="auto">
+          <a:xfrm>
+            <a:off x="186611" y="418356"/>
+            <a:ext cx="7338139" cy="3855659"/>
+          </a:xfrm>
+          <a:prstGeom prst="rect">
+            <a:avLst/>
+          </a:prstGeom>
+          <a:noFill/>
+          <a:extLst>
+            <a:ext uri="{909E8E84-426E-40DD-AFC4-6F175D3DCCD1}">
+              <a14:hiddenFill xmlns:a14="http://schemas.microsoft.com/office/drawing/2010/main">
+                <a:solidFill>
+                  <a:srgbClr val="FFFFFF"/>
+                </a:solidFill>
+              </a14:hiddenFill>
+            </a:ext>
+          </a:extLst>
+        </p:spPr>
+      </p:pic>
     </p:spTree>
     <p:extLst>
       <p:ext uri="{BB962C8B-B14F-4D97-AF65-F5344CB8AC3E}">
-        <p14:creationId xmlns:p14="http://schemas.microsoft.com/office/powerpoint/2010/main" val="3116847344"/>
+        <p14:creationId xmlns:p14="http://schemas.microsoft.com/office/powerpoint/2010/main" val="3769292591"/>
       </p:ext>
     </p:extLst>
   </p:cSld>

</xml_diff>